<commit_message>
Rodada B: revisão de deck existente, rubrica de qualidade, paginação de tabelas, template corporativo
- 00-guia/revisao-de-deck-existente.md + extract_deck.py (outline, teste dos títulos, diagnóstico, spec aproximada para reconstrução)
- 07-checklists/rubrica-de-qualidade.md + score_deck.py (critérios automáticos + manuais, total ponderado)
- add_table pagina tabelas acima de max_rows em slides (i/n)
- meta.template / template_branding / template_layouts: usa layouts e placeholders do arquivo corporativo; 05-artefatos-visuais/template-corporativo.md + template-exemplo.pptx
- rodapé de confidencialidade derivado de meta.exposure quando não informado

Co-Authored-By: Claude Fable 5.1 <noreply@anthropic.com>
</commit_message>
<xml_diff>
--- a/examples/todos-os-modelos.pptx
+++ b/examples/todos-os-modelos.pptx
@@ -36,6 +36,10 @@
     <p:sldId id="284" r:id="rId36"/>
     <p:sldId id="285" r:id="rId37"/>
     <p:sldId id="286" r:id="rId38"/>
+    <p:sldId id="287" r:id="rId39"/>
+    <p:sldId id="288" r:id="rId40"/>
+    <p:sldId id="289" r:id="rId41"/>
+    <p:sldId id="290" r:id="rId42"/>
   </p:sldIdLst>
   <p:sldSz cx="12191695" cy="6858000" type="screen4x3"/>
   <p:notesSz cx="6858000" cy="9144000"/>
@@ -20545,6 +20549,4886 @@
 </file>
 
 <file path=ppt/slides/slide31.xml><?xml version="1.0" encoding="utf-8"?>
+<p:sld xmlns:a="http://schemas.openxmlformats.org/drawingml/2006/main" xmlns:p="http://schemas.openxmlformats.org/presentationml/2006/main" xmlns:r="http://schemas.openxmlformats.org/officeDocument/2006/relationships">
+  <p:cSld>
+    <p:bg>
+      <p:bgPr>
+        <a:solidFill>
+          <a:srgbClr val="1F3A5F"/>
+        </a:solidFill>
+        <a:effectLst/>
+      </p:bgPr>
+    </p:bg>
+    <p:spTree>
+      <p:nvGrpSpPr>
+        <p:cNvPr id="1" name=""/>
+        <p:cNvGrpSpPr/>
+        <p:nvPr/>
+      </p:nvGrpSpPr>
+      <p:grpSpPr/>
+      <p:sp>
+        <p:nvSpPr>
+          <p:cNvPr id="2" name="TextBox 1"/>
+          <p:cNvSpPr txBox="1"/>
+          <p:nvPr/>
+        </p:nvSpPr>
+        <p:spPr>
+          <a:xfrm>
+            <a:off x="731520" y="2011680"/>
+            <a:ext cx="1828800" cy="914400"/>
+          </a:xfrm>
+          <a:prstGeom prst="rect">
+            <a:avLst/>
+          </a:prstGeom>
+          <a:noFill/>
+        </p:spPr>
+        <p:txBody>
+          <a:bodyPr wrap="square" anchor="t" lIns="45720" rIns="45720" tIns="27432" bIns="27432">
+            <a:spAutoFit/>
+          </a:bodyPr>
+          <a:lstStyle/>
+          <a:p>
+            <a:pPr algn="l"/>
+            <a:r>
+              <a:rPr sz="6000" b="1" i="0">
+                <a:solidFill>
+                  <a:srgbClr val="F2A900"/>
+                </a:solidFill>
+                <a:latin typeface="Calibri"/>
+              </a:rPr>
+              <a:t>A</a:t>
+            </a:r>
+          </a:p>
+        </p:txBody>
+      </p:sp>
+      <p:sp>
+        <p:nvSpPr>
+          <p:cNvPr id="3" name="TextBox 2"/>
+          <p:cNvSpPr txBox="1"/>
+          <p:nvPr/>
+        </p:nvSpPr>
+        <p:spPr>
+          <a:xfrm>
+            <a:off x="731520" y="3017520"/>
+            <a:ext cx="10698480" cy="1097280"/>
+          </a:xfrm>
+          <a:prstGeom prst="rect">
+            <a:avLst/>
+          </a:prstGeom>
+          <a:noFill/>
+        </p:spPr>
+        <p:txBody>
+          <a:bodyPr wrap="square" anchor="t" lIns="45720" rIns="45720" tIns="27432" bIns="27432">
+            <a:spAutoFit/>
+          </a:bodyPr>
+          <a:lstStyle/>
+          <a:p>
+            <a:pPr algn="l"/>
+            <a:r>
+              <a:rPr sz="3600" b="1" i="0">
+                <a:solidFill>
+                  <a:srgbClr val="FFFFFF"/>
+                </a:solidFill>
+                <a:latin typeface="Calibri"/>
+              </a:rPr>
+              <a:t>Anexos</a:t>
+            </a:r>
+          </a:p>
+        </p:txBody>
+      </p:sp>
+      <p:pic>
+        <p:nvPicPr>
+          <p:cNvPr id="4" name="Picture 3" descr="logo-placeholder-light.png"/>
+          <p:cNvPicPr>
+            <a:picLocks noChangeAspect="1"/>
+          </p:cNvPicPr>
+          <p:nvPr/>
+        </p:nvPicPr>
+        <p:blipFill>
+          <a:blip r:embed="rId2"/>
+          <a:stretch>
+            <a:fillRect/>
+          </a:stretch>
+        </p:blipFill>
+        <p:spPr>
+          <a:xfrm>
+            <a:off x="10607040" y="457200"/>
+            <a:ext cx="1097280" cy="365760"/>
+          </a:xfrm>
+          <a:prstGeom prst="rect">
+            <a:avLst/>
+          </a:prstGeom>
+        </p:spPr>
+      </p:pic>
+    </p:spTree>
+  </p:cSld>
+  <p:clrMapOvr>
+    <a:masterClrMapping/>
+  </p:clrMapOvr>
+</p:sld>
+</file>
+
+<file path=ppt/slides/slide32.xml><?xml version="1.0" encoding="utf-8"?>
+<p:sld xmlns:a="http://schemas.openxmlformats.org/drawingml/2006/main" xmlns:p="http://schemas.openxmlformats.org/presentationml/2006/main" xmlns:r="http://schemas.openxmlformats.org/officeDocument/2006/relationships">
+  <p:cSld>
+    <p:spTree>
+      <p:nvGrpSpPr>
+        <p:cNvPr id="1" name=""/>
+        <p:cNvGrpSpPr/>
+        <p:nvPr/>
+      </p:nvGrpSpPr>
+      <p:grpSpPr/>
+      <p:sp>
+        <p:nvSpPr>
+          <p:cNvPr id="2" name="Title 1"/>
+          <p:cNvSpPr>
+            <a:spLocks noGrp="1"/>
+          </p:cNvSpPr>
+          <p:nvPr>
+            <p:ph type="title"/>
+          </p:nvPr>
+        </p:nvSpPr>
+        <p:spPr>
+          <a:xfrm>
+            <a:off x="457200" y="621792"/>
+            <a:ext cx="11274552" cy="822960"/>
+          </a:xfrm>
+        </p:spPr>
+        <p:txBody>
+          <a:bodyPr wrap="square" anchor="t" lIns="45720" rIns="45720"/>
+          <a:lstStyle/>
+          <a:p>
+            <a:pPr algn="l"/>
+            <a:r>
+              <a:rPr sz="2800" b="1" i="0">
+                <a:solidFill>
+                  <a:srgbClr val="1F3A5F"/>
+                </a:solidFill>
+                <a:latin typeface="Calibri"/>
+              </a:rPr>
+              <a:t>Tabela longa paginada automaticamente (25 linhas) (1/3)</a:t>
+            </a:r>
+          </a:p>
+        </p:txBody>
+      </p:sp>
+      <p:sp>
+        <p:nvSpPr>
+          <p:cNvPr id="3" name="TextBox 2"/>
+          <p:cNvSpPr txBox="1"/>
+          <p:nvPr/>
+        </p:nvSpPr>
+        <p:spPr>
+          <a:xfrm>
+            <a:off x="457200" y="91440"/>
+            <a:ext cx="7315200" cy="228600"/>
+          </a:xfrm>
+          <a:prstGeom prst="rect">
+            <a:avLst/>
+          </a:prstGeom>
+          <a:noFill/>
+        </p:spPr>
+        <p:txBody>
+          <a:bodyPr wrap="square" anchor="ctr" lIns="45720" rIns="45720" tIns="27432" bIns="27432">
+            <a:spAutoFit/>
+          </a:bodyPr>
+          <a:lstStyle/>
+          <a:p>
+            <a:pPr algn="l"/>
+            <a:r>
+              <a:rPr sz="900" b="1" i="0">
+                <a:solidFill>
+                  <a:srgbClr val="8C8C8C"/>
+                </a:solidFill>
+                <a:latin typeface="Calibri"/>
+              </a:rPr>
+              <a:t>EMPRESA EXEMPLO  |  CATÁLOGO DE MODELOS</a:t>
+            </a:r>
+          </a:p>
+        </p:txBody>
+      </p:sp>
+      <p:sp>
+        <p:nvSpPr>
+          <p:cNvPr id="4" name="TextBox 3"/>
+          <p:cNvSpPr txBox="1"/>
+          <p:nvPr/>
+        </p:nvSpPr>
+        <p:spPr>
+          <a:xfrm>
+            <a:off x="7772400" y="91440"/>
+            <a:ext cx="3959352" cy="228600"/>
+          </a:xfrm>
+          <a:prstGeom prst="rect">
+            <a:avLst/>
+          </a:prstGeom>
+          <a:noFill/>
+        </p:spPr>
+        <p:txBody>
+          <a:bodyPr wrap="square" anchor="ctr" lIns="45720" rIns="45720" tIns="27432" bIns="27432">
+            <a:spAutoFit/>
+          </a:bodyPr>
+          <a:lstStyle/>
+          <a:p>
+            <a:pPr algn="r"/>
+            <a:r>
+              <a:rPr sz="900" b="0" i="0">
+                <a:solidFill>
+                  <a:srgbClr val="8C8C8C"/>
+                </a:solidFill>
+                <a:latin typeface="Calibri"/>
+              </a:rPr>
+              <a:t>set/2026</a:t>
+            </a:r>
+          </a:p>
+        </p:txBody>
+      </p:sp>
+      <p:sp>
+        <p:nvSpPr>
+          <p:cNvPr id="5" name="TextBox 4"/>
+          <p:cNvSpPr txBox="1"/>
+          <p:nvPr/>
+        </p:nvSpPr>
+        <p:spPr>
+          <a:xfrm>
+            <a:off x="457200" y="384048"/>
+            <a:ext cx="11274552" cy="256032"/>
+          </a:xfrm>
+          <a:prstGeom prst="rect">
+            <a:avLst/>
+          </a:prstGeom>
+          <a:noFill/>
+        </p:spPr>
+        <p:txBody>
+          <a:bodyPr wrap="square" anchor="b" lIns="45720" rIns="45720" tIns="27432" bIns="27432">
+            <a:spAutoFit/>
+          </a:bodyPr>
+          <a:lstStyle/>
+          <a:p>
+            <a:pPr algn="l"/>
+            <a:r>
+              <a:rPr sz="1000" b="1" i="0">
+                <a:solidFill>
+                  <a:srgbClr val="4F81BD"/>
+                </a:solidFill>
+                <a:latin typeface="Calibri"/>
+              </a:rPr>
+              <a:t>ANEXO</a:t>
+            </a:r>
+          </a:p>
+        </p:txBody>
+      </p:sp>
+      <p:sp>
+        <p:nvSpPr>
+          <p:cNvPr id="6" name="TextBox 5"/>
+          <p:cNvSpPr txBox="1"/>
+          <p:nvPr/>
+        </p:nvSpPr>
+        <p:spPr>
+          <a:xfrm>
+            <a:off x="457200" y="6217920"/>
+            <a:ext cx="8531352" cy="365760"/>
+          </a:xfrm>
+          <a:prstGeom prst="rect">
+            <a:avLst/>
+          </a:prstGeom>
+          <a:noFill/>
+        </p:spPr>
+        <p:txBody>
+          <a:bodyPr wrap="square" anchor="ctr" lIns="45720" rIns="45720" tIns="27432" bIns="27432">
+            <a:spAutoFit/>
+          </a:bodyPr>
+          <a:lstStyle/>
+          <a:p>
+            <a:pPr algn="l"/>
+            <a:r>
+              <a:rPr sz="1000" b="0" i="0">
+                <a:solidFill>
+                  <a:srgbClr val="8C8C8C"/>
+                </a:solidFill>
+                <a:latin typeface="Calibri"/>
+              </a:rPr>
+              <a:t>Fonte: Base de portfólio (exemplo)   |   Uso interno</a:t>
+            </a:r>
+          </a:p>
+        </p:txBody>
+      </p:sp>
+      <p:sp>
+        <p:nvSpPr>
+          <p:cNvPr id="7" name="TextBox 6"/>
+          <p:cNvSpPr txBox="1"/>
+          <p:nvPr/>
+        </p:nvSpPr>
+        <p:spPr>
+          <a:xfrm>
+            <a:off x="10817352" y="6217920"/>
+            <a:ext cx="914400" cy="365760"/>
+          </a:xfrm>
+          <a:prstGeom prst="rect">
+            <a:avLst/>
+          </a:prstGeom>
+          <a:noFill/>
+        </p:spPr>
+        <p:txBody>
+          <a:bodyPr wrap="square" anchor="ctr" lIns="45720" rIns="45720" tIns="27432" bIns="27432">
+            <a:spAutoFit/>
+          </a:bodyPr>
+          <a:lstStyle/>
+          <a:p>
+            <a:pPr algn="r"/>
+            <a:r>
+              <a:rPr sz="1000" b="0" i="0">
+                <a:solidFill>
+                  <a:srgbClr val="8C8C8C"/>
+                </a:solidFill>
+                <a:latin typeface="Calibri"/>
+              </a:rPr>
+              <a:t>32</a:t>
+            </a:r>
+          </a:p>
+        </p:txBody>
+      </p:sp>
+      <p:pic>
+        <p:nvPicPr>
+          <p:cNvPr id="8" name="Picture 7" descr="logo-placeholder.png"/>
+          <p:cNvPicPr>
+            <a:picLocks noChangeAspect="1"/>
+          </p:cNvPicPr>
+          <p:nvPr/>
+        </p:nvPicPr>
+        <p:blipFill>
+          <a:blip r:embed="rId2"/>
+          <a:stretch>
+            <a:fillRect/>
+          </a:stretch>
+        </p:blipFill>
+        <p:spPr>
+          <a:xfrm>
+            <a:off x="9692640" y="6245352"/>
+            <a:ext cx="822960" cy="274320"/>
+          </a:xfrm>
+          <a:prstGeom prst="rect">
+            <a:avLst/>
+          </a:prstGeom>
+        </p:spPr>
+      </p:pic>
+      <p:graphicFrame>
+        <p:nvGraphicFramePr>
+          <p:cNvPr id="9" name="Table 8"/>
+          <p:cNvGraphicFramePr>
+            <a:graphicFrameLocks noGrp="1"/>
+          </p:cNvGraphicFramePr>
+          <p:nvPr/>
+        </p:nvGraphicFramePr>
+        <p:xfrm>
+          <a:off x="457200" y="1737360"/>
+          <a:ext cx="11274552" cy="4389120"/>
+        </p:xfrm>
+        <a:graphic>
+          <a:graphicData uri="http://schemas.openxmlformats.org/drawingml/2006/table">
+            <a:tbl>
+              <a:tblPr firstRow="1">
+                <a:tableStyleId>{5C22544A-7EE6-4342-B048-85BDC9FD1C3A}</a:tableStyleId>
+              </a:tblPr>
+              <a:tblGrid>
+                <a:gridCol w="1879092"/>
+                <a:gridCol w="1879092"/>
+                <a:gridCol w="1879092"/>
+                <a:gridCol w="1879092"/>
+                <a:gridCol w="1879092"/>
+                <a:gridCol w="1879092"/>
+              </a:tblGrid>
+              <a:tr h="399010">
+                <a:tc>
+                  <a:txBody>
+                    <a:bodyPr wrap="square"/>
+                    <a:lstStyle/>
+                    <a:p>
+                      <a:pPr algn="l"/>
+                      <a:r>
+                        <a:rPr sz="1200" b="1" i="0">
+                          <a:solidFill>
+                            <a:srgbClr val="FFFFFF"/>
+                          </a:solidFill>
+                          <a:latin typeface="Calibri"/>
+                        </a:rPr>
+                        <a:t>ID</a:t>
+                      </a:r>
+                    </a:p>
+                  </a:txBody>
+                  <a:tcPr marL="73152" marR="73152" marT="27432" marB="27432" anchor="ctr">
+                    <a:solidFill>
+                      <a:srgbClr val="1F3A5F"/>
+                    </a:solidFill>
+                  </a:tcPr>
+                </a:tc>
+                <a:tc>
+                  <a:txBody>
+                    <a:bodyPr wrap="square"/>
+                    <a:lstStyle/>
+                    <a:p>
+                      <a:pPr algn="l"/>
+                      <a:r>
+                        <a:rPr sz="1200" b="1" i="0">
+                          <a:solidFill>
+                            <a:srgbClr val="FFFFFF"/>
+                          </a:solidFill>
+                          <a:latin typeface="Calibri"/>
+                        </a:rPr>
+                        <a:t>Projeto</a:t>
+                      </a:r>
+                    </a:p>
+                  </a:txBody>
+                  <a:tcPr marL="73152" marR="73152" marT="27432" marB="27432" anchor="ctr">
+                    <a:solidFill>
+                      <a:srgbClr val="1F3A5F"/>
+                    </a:solidFill>
+                  </a:tcPr>
+                </a:tc>
+                <a:tc>
+                  <a:txBody>
+                    <a:bodyPr wrap="square"/>
+                    <a:lstStyle/>
+                    <a:p>
+                      <a:pPr algn="l"/>
+                      <a:r>
+                        <a:rPr sz="1200" b="1" i="0">
+                          <a:solidFill>
+                            <a:srgbClr val="FFFFFF"/>
+                          </a:solidFill>
+                          <a:latin typeface="Calibri"/>
+                        </a:rPr>
+                        <a:t>Status</a:t>
+                      </a:r>
+                    </a:p>
+                  </a:txBody>
+                  <a:tcPr marL="73152" marR="73152" marT="27432" marB="27432" anchor="ctr">
+                    <a:solidFill>
+                      <a:srgbClr val="1F3A5F"/>
+                    </a:solidFill>
+                  </a:tcPr>
+                </a:tc>
+                <a:tc>
+                  <a:txBody>
+                    <a:bodyPr wrap="square"/>
+                    <a:lstStyle/>
+                    <a:p>
+                      <a:pPr algn="ctr"/>
+                      <a:r>
+                        <a:rPr sz="1200" b="1" i="0">
+                          <a:solidFill>
+                            <a:srgbClr val="FFFFFF"/>
+                          </a:solidFill>
+                          <a:latin typeface="Calibri"/>
+                        </a:rPr>
+                        <a:t>Risco</a:t>
+                      </a:r>
+                    </a:p>
+                  </a:txBody>
+                  <a:tcPr marL="73152" marR="73152" marT="27432" marB="27432" anchor="ctr">
+                    <a:solidFill>
+                      <a:srgbClr val="1F3A5F"/>
+                    </a:solidFill>
+                  </a:tcPr>
+                </a:tc>
+                <a:tc>
+                  <a:txBody>
+                    <a:bodyPr wrap="square"/>
+                    <a:lstStyle/>
+                    <a:p>
+                      <a:pPr algn="r"/>
+                      <a:r>
+                        <a:rPr sz="1200" b="1" i="0">
+                          <a:solidFill>
+                            <a:srgbClr val="FFFFFF"/>
+                          </a:solidFill>
+                          <a:latin typeface="Calibri"/>
+                        </a:rPr>
+                        <a:t>Conclusão</a:t>
+                      </a:r>
+                    </a:p>
+                  </a:txBody>
+                  <a:tcPr marL="73152" marR="73152" marT="27432" marB="27432" anchor="ctr">
+                    <a:solidFill>
+                      <a:srgbClr val="1F3A5F"/>
+                    </a:solidFill>
+                  </a:tcPr>
+                </a:tc>
+                <a:tc>
+                  <a:txBody>
+                    <a:bodyPr wrap="square"/>
+                    <a:lstStyle/>
+                    <a:p>
+                      <a:pPr algn="r"/>
+                      <a:r>
+                        <a:rPr sz="1200" b="1" i="0">
+                          <a:solidFill>
+                            <a:srgbClr val="FFFFFF"/>
+                          </a:solidFill>
+                          <a:latin typeface="Calibri"/>
+                        </a:rPr>
+                        <a:t>Orçamento</a:t>
+                      </a:r>
+                    </a:p>
+                  </a:txBody>
+                  <a:tcPr marL="73152" marR="73152" marT="27432" marB="27432" anchor="ctr">
+                    <a:solidFill>
+                      <a:srgbClr val="1F3A5F"/>
+                    </a:solidFill>
+                  </a:tcPr>
+                </a:tc>
+              </a:tr>
+              <a:tr h="399010">
+                <a:tc>
+                  <a:txBody>
+                    <a:bodyPr wrap="square"/>
+                    <a:lstStyle/>
+                    <a:p>
+                      <a:pPr algn="l"/>
+                      <a:r>
+                        <a:rPr sz="1200" b="0" i="0">
+                          <a:solidFill>
+                            <a:srgbClr val="333333"/>
+                          </a:solidFill>
+                          <a:latin typeface="Calibri"/>
+                        </a:rPr>
+                        <a:t>P-001</a:t>
+                      </a:r>
+                    </a:p>
+                  </a:txBody>
+                  <a:tcPr marL="73152" marR="73152" marT="27432" marB="27432" anchor="ctr">
+                    <a:solidFill>
+                      <a:srgbClr val="FFFFFF"/>
+                    </a:solidFill>
+                  </a:tcPr>
+                </a:tc>
+                <a:tc>
+                  <a:txBody>
+                    <a:bodyPr wrap="square"/>
+                    <a:lstStyle/>
+                    <a:p>
+                      <a:pPr algn="l"/>
+                      <a:r>
+                        <a:rPr sz="1200" b="0" i="0">
+                          <a:solidFill>
+                            <a:srgbClr val="333333"/>
+                          </a:solidFill>
+                          <a:latin typeface="Calibri"/>
+                        </a:rPr>
+                        <a:t>Projeto 1</a:t>
+                      </a:r>
+                    </a:p>
+                  </a:txBody>
+                  <a:tcPr marL="73152" marR="73152" marT="27432" marB="27432" anchor="ctr">
+                    <a:solidFill>
+                      <a:srgbClr val="FFFFFF"/>
+                    </a:solidFill>
+                  </a:tcPr>
+                </a:tc>
+                <a:tc>
+                  <a:txBody>
+                    <a:bodyPr wrap="square"/>
+                    <a:lstStyle/>
+                    <a:p>
+                      <a:pPr algn="l"/>
+                      <a:r>
+                        <a:rPr sz="1200" b="0" i="0">
+                          <a:solidFill>
+                            <a:srgbClr val="333333"/>
+                          </a:solidFill>
+                          <a:latin typeface="Calibri"/>
+                        </a:rPr>
+                        <a:t>Em andamento</a:t>
+                      </a:r>
+                    </a:p>
+                  </a:txBody>
+                  <a:tcPr marL="73152" marR="73152" marT="27432" marB="27432" anchor="ctr">
+                    <a:solidFill>
+                      <a:srgbClr val="FFFFFF"/>
+                    </a:solidFill>
+                  </a:tcPr>
+                </a:tc>
+                <a:tc>
+                  <a:txBody>
+                    <a:bodyPr wrap="square"/>
+                    <a:lstStyle/>
+                    <a:p>
+                      <a:pPr algn="ctr"/>
+                      <a:r>
+                        <a:rPr sz="1200" b="1" i="0">
+                          <a:solidFill>
+                            <a:srgbClr val="FFFFFF"/>
+                          </a:solidFill>
+                          <a:latin typeface="Calibri"/>
+                        </a:rPr>
+                        <a:t>Médio</a:t>
+                      </a:r>
+                    </a:p>
+                  </a:txBody>
+                  <a:tcPr marL="73152" marR="73152" marT="27432" marB="27432" anchor="ctr">
+                    <a:solidFill>
+                      <a:srgbClr val="F9A825"/>
+                    </a:solidFill>
+                  </a:tcPr>
+                </a:tc>
+                <a:tc>
+                  <a:txBody>
+                    <a:bodyPr wrap="square"/>
+                    <a:lstStyle/>
+                    <a:p>
+                      <a:pPr algn="r"/>
+                      <a:r>
+                        <a:rPr sz="1200" b="0" i="0">
+                          <a:solidFill>
+                            <a:srgbClr val="333333"/>
+                          </a:solidFill>
+                          <a:latin typeface="Calibri"/>
+                        </a:rPr>
+                        <a:t>31%</a:t>
+                      </a:r>
+                    </a:p>
+                  </a:txBody>
+                  <a:tcPr marL="73152" marR="73152" marT="27432" marB="27432" anchor="ctr">
+                    <a:solidFill>
+                      <a:srgbClr val="FFFFFF"/>
+                    </a:solidFill>
+                  </a:tcPr>
+                </a:tc>
+                <a:tc>
+                  <a:txBody>
+                    <a:bodyPr wrap="square"/>
+                    <a:lstStyle/>
+                    <a:p>
+                      <a:pPr algn="r"/>
+                      <a:r>
+                        <a:rPr sz="1200" b="0" i="0">
+                          <a:solidFill>
+                            <a:srgbClr val="333333"/>
+                          </a:solidFill>
+                          <a:latin typeface="Calibri"/>
+                        </a:rPr>
+                        <a:t>R$ 1,1 mi</a:t>
+                      </a:r>
+                    </a:p>
+                  </a:txBody>
+                  <a:tcPr marL="73152" marR="73152" marT="27432" marB="27432" anchor="ctr">
+                    <a:solidFill>
+                      <a:srgbClr val="FFFFFF"/>
+                    </a:solidFill>
+                  </a:tcPr>
+                </a:tc>
+              </a:tr>
+              <a:tr h="399010">
+                <a:tc>
+                  <a:txBody>
+                    <a:bodyPr wrap="square"/>
+                    <a:lstStyle/>
+                    <a:p>
+                      <a:pPr algn="l"/>
+                      <a:r>
+                        <a:rPr sz="1200" b="0" i="0">
+                          <a:solidFill>
+                            <a:srgbClr val="333333"/>
+                          </a:solidFill>
+                          <a:latin typeface="Calibri"/>
+                        </a:rPr>
+                        <a:t>P-002</a:t>
+                      </a:r>
+                    </a:p>
+                  </a:txBody>
+                  <a:tcPr marL="73152" marR="73152" marT="27432" marB="27432" anchor="ctr">
+                    <a:solidFill>
+                      <a:srgbClr val="F2F2F2"/>
+                    </a:solidFill>
+                  </a:tcPr>
+                </a:tc>
+                <a:tc>
+                  <a:txBody>
+                    <a:bodyPr wrap="square"/>
+                    <a:lstStyle/>
+                    <a:p>
+                      <a:pPr algn="l"/>
+                      <a:r>
+                        <a:rPr sz="1200" b="0" i="0">
+                          <a:solidFill>
+                            <a:srgbClr val="333333"/>
+                          </a:solidFill>
+                          <a:latin typeface="Calibri"/>
+                        </a:rPr>
+                        <a:t>Projeto 2</a:t>
+                      </a:r>
+                    </a:p>
+                  </a:txBody>
+                  <a:tcPr marL="73152" marR="73152" marT="27432" marB="27432" anchor="ctr">
+                    <a:solidFill>
+                      <a:srgbClr val="F2F2F2"/>
+                    </a:solidFill>
+                  </a:tcPr>
+                </a:tc>
+                <a:tc>
+                  <a:txBody>
+                    <a:bodyPr wrap="square"/>
+                    <a:lstStyle/>
+                    <a:p>
+                      <a:pPr algn="l"/>
+                      <a:r>
+                        <a:rPr sz="1200" b="0" i="0">
+                          <a:solidFill>
+                            <a:srgbClr val="333333"/>
+                          </a:solidFill>
+                          <a:latin typeface="Calibri"/>
+                        </a:rPr>
+                        <a:t>Em andamento</a:t>
+                      </a:r>
+                    </a:p>
+                  </a:txBody>
+                  <a:tcPr marL="73152" marR="73152" marT="27432" marB="27432" anchor="ctr">
+                    <a:solidFill>
+                      <a:srgbClr val="F2F2F2"/>
+                    </a:solidFill>
+                  </a:tcPr>
+                </a:tc>
+                <a:tc>
+                  <a:txBody>
+                    <a:bodyPr wrap="square"/>
+                    <a:lstStyle/>
+                    <a:p>
+                      <a:pPr algn="ctr"/>
+                      <a:r>
+                        <a:rPr sz="1200" b="1" i="0">
+                          <a:solidFill>
+                            <a:srgbClr val="FFFFFF"/>
+                          </a:solidFill>
+                          <a:latin typeface="Calibri"/>
+                        </a:rPr>
+                        <a:t>Médio</a:t>
+                      </a:r>
+                    </a:p>
+                  </a:txBody>
+                  <a:tcPr marL="73152" marR="73152" marT="27432" marB="27432" anchor="ctr">
+                    <a:solidFill>
+                      <a:srgbClr val="F9A825"/>
+                    </a:solidFill>
+                  </a:tcPr>
+                </a:tc>
+                <a:tc>
+                  <a:txBody>
+                    <a:bodyPr wrap="square"/>
+                    <a:lstStyle/>
+                    <a:p>
+                      <a:pPr algn="r"/>
+                      <a:r>
+                        <a:rPr sz="1200" b="0" i="0">
+                          <a:solidFill>
+                            <a:srgbClr val="333333"/>
+                          </a:solidFill>
+                          <a:latin typeface="Calibri"/>
+                        </a:rPr>
+                        <a:t>32%</a:t>
+                      </a:r>
+                    </a:p>
+                  </a:txBody>
+                  <a:tcPr marL="73152" marR="73152" marT="27432" marB="27432" anchor="ctr">
+                    <a:solidFill>
+                      <a:srgbClr val="F2F2F2"/>
+                    </a:solidFill>
+                  </a:tcPr>
+                </a:tc>
+                <a:tc>
+                  <a:txBody>
+                    <a:bodyPr wrap="square"/>
+                    <a:lstStyle/>
+                    <a:p>
+                      <a:pPr algn="r"/>
+                      <a:r>
+                        <a:rPr sz="1200" b="0" i="0">
+                          <a:solidFill>
+                            <a:srgbClr val="333333"/>
+                          </a:solidFill>
+                          <a:latin typeface="Calibri"/>
+                        </a:rPr>
+                        <a:t>R$ 1,2 mi</a:t>
+                      </a:r>
+                    </a:p>
+                  </a:txBody>
+                  <a:tcPr marL="73152" marR="73152" marT="27432" marB="27432" anchor="ctr">
+                    <a:solidFill>
+                      <a:srgbClr val="F2F2F2"/>
+                    </a:solidFill>
+                  </a:tcPr>
+                </a:tc>
+              </a:tr>
+              <a:tr h="399010">
+                <a:tc>
+                  <a:txBody>
+                    <a:bodyPr wrap="square"/>
+                    <a:lstStyle/>
+                    <a:p>
+                      <a:pPr algn="l"/>
+                      <a:r>
+                        <a:rPr sz="1200" b="0" i="0">
+                          <a:solidFill>
+                            <a:srgbClr val="333333"/>
+                          </a:solidFill>
+                          <a:latin typeface="Calibri"/>
+                        </a:rPr>
+                        <a:t>P-003</a:t>
+                      </a:r>
+                    </a:p>
+                  </a:txBody>
+                  <a:tcPr marL="73152" marR="73152" marT="27432" marB="27432" anchor="ctr">
+                    <a:solidFill>
+                      <a:srgbClr val="FFFFFF"/>
+                    </a:solidFill>
+                  </a:tcPr>
+                </a:tc>
+                <a:tc>
+                  <a:txBody>
+                    <a:bodyPr wrap="square"/>
+                    <a:lstStyle/>
+                    <a:p>
+                      <a:pPr algn="l"/>
+                      <a:r>
+                        <a:rPr sz="1200" b="0" i="0">
+                          <a:solidFill>
+                            <a:srgbClr val="333333"/>
+                          </a:solidFill>
+                          <a:latin typeface="Calibri"/>
+                        </a:rPr>
+                        <a:t>Projeto 3</a:t>
+                      </a:r>
+                    </a:p>
+                  </a:txBody>
+                  <a:tcPr marL="73152" marR="73152" marT="27432" marB="27432" anchor="ctr">
+                    <a:solidFill>
+                      <a:srgbClr val="FFFFFF"/>
+                    </a:solidFill>
+                  </a:tcPr>
+                </a:tc>
+                <a:tc>
+                  <a:txBody>
+                    <a:bodyPr wrap="square"/>
+                    <a:lstStyle/>
+                    <a:p>
+                      <a:pPr algn="l"/>
+                      <a:r>
+                        <a:rPr sz="1200" b="0" i="0">
+                          <a:solidFill>
+                            <a:srgbClr val="333333"/>
+                          </a:solidFill>
+                          <a:latin typeface="Calibri"/>
+                        </a:rPr>
+                        <a:t>Validação</a:t>
+                      </a:r>
+                    </a:p>
+                  </a:txBody>
+                  <a:tcPr marL="73152" marR="73152" marT="27432" marB="27432" anchor="ctr">
+                    <a:solidFill>
+                      <a:srgbClr val="FFFFFF"/>
+                    </a:solidFill>
+                  </a:tcPr>
+                </a:tc>
+                <a:tc>
+                  <a:txBody>
+                    <a:bodyPr wrap="square"/>
+                    <a:lstStyle/>
+                    <a:p>
+                      <a:pPr algn="ctr"/>
+                      <a:r>
+                        <a:rPr sz="1200" b="1" i="0">
+                          <a:solidFill>
+                            <a:srgbClr val="FFFFFF"/>
+                          </a:solidFill>
+                          <a:latin typeface="Calibri"/>
+                        </a:rPr>
+                        <a:t>Médio</a:t>
+                      </a:r>
+                    </a:p>
+                  </a:txBody>
+                  <a:tcPr marL="73152" marR="73152" marT="27432" marB="27432" anchor="ctr">
+                    <a:solidFill>
+                      <a:srgbClr val="F9A825"/>
+                    </a:solidFill>
+                  </a:tcPr>
+                </a:tc>
+                <a:tc>
+                  <a:txBody>
+                    <a:bodyPr wrap="square"/>
+                    <a:lstStyle/>
+                    <a:p>
+                      <a:pPr algn="r"/>
+                      <a:r>
+                        <a:rPr sz="1200" b="0" i="0">
+                          <a:solidFill>
+                            <a:srgbClr val="333333"/>
+                          </a:solidFill>
+                          <a:latin typeface="Calibri"/>
+                        </a:rPr>
+                        <a:t>33%</a:t>
+                      </a:r>
+                    </a:p>
+                  </a:txBody>
+                  <a:tcPr marL="73152" marR="73152" marT="27432" marB="27432" anchor="ctr">
+                    <a:solidFill>
+                      <a:srgbClr val="FFFFFF"/>
+                    </a:solidFill>
+                  </a:tcPr>
+                </a:tc>
+                <a:tc>
+                  <a:txBody>
+                    <a:bodyPr wrap="square"/>
+                    <a:lstStyle/>
+                    <a:p>
+                      <a:pPr algn="r"/>
+                      <a:r>
+                        <a:rPr sz="1200" b="0" i="0">
+                          <a:solidFill>
+                            <a:srgbClr val="333333"/>
+                          </a:solidFill>
+                          <a:latin typeface="Calibri"/>
+                        </a:rPr>
+                        <a:t>R$ 1,3 mi</a:t>
+                      </a:r>
+                    </a:p>
+                  </a:txBody>
+                  <a:tcPr marL="73152" marR="73152" marT="27432" marB="27432" anchor="ctr">
+                    <a:solidFill>
+                      <a:srgbClr val="FFFFFF"/>
+                    </a:solidFill>
+                  </a:tcPr>
+                </a:tc>
+              </a:tr>
+              <a:tr h="399010">
+                <a:tc>
+                  <a:txBody>
+                    <a:bodyPr wrap="square"/>
+                    <a:lstStyle/>
+                    <a:p>
+                      <a:pPr algn="l"/>
+                      <a:r>
+                        <a:rPr sz="1200" b="0" i="0">
+                          <a:solidFill>
+                            <a:srgbClr val="333333"/>
+                          </a:solidFill>
+                          <a:latin typeface="Calibri"/>
+                        </a:rPr>
+                        <a:t>P-004</a:t>
+                      </a:r>
+                    </a:p>
+                  </a:txBody>
+                  <a:tcPr marL="73152" marR="73152" marT="27432" marB="27432" anchor="ctr">
+                    <a:solidFill>
+                      <a:srgbClr val="F2F2F2"/>
+                    </a:solidFill>
+                  </a:tcPr>
+                </a:tc>
+                <a:tc>
+                  <a:txBody>
+                    <a:bodyPr wrap="square"/>
+                    <a:lstStyle/>
+                    <a:p>
+                      <a:pPr algn="l"/>
+                      <a:r>
+                        <a:rPr sz="1200" b="0" i="0">
+                          <a:solidFill>
+                            <a:srgbClr val="333333"/>
+                          </a:solidFill>
+                          <a:latin typeface="Calibri"/>
+                        </a:rPr>
+                        <a:t>Projeto 4</a:t>
+                      </a:r>
+                    </a:p>
+                  </a:txBody>
+                  <a:tcPr marL="73152" marR="73152" marT="27432" marB="27432" anchor="ctr">
+                    <a:solidFill>
+                      <a:srgbClr val="F2F2F2"/>
+                    </a:solidFill>
+                  </a:tcPr>
+                </a:tc>
+                <a:tc>
+                  <a:txBody>
+                    <a:bodyPr wrap="square"/>
+                    <a:lstStyle/>
+                    <a:p>
+                      <a:pPr algn="l"/>
+                      <a:r>
+                        <a:rPr sz="1200" b="0" i="0">
+                          <a:solidFill>
+                            <a:srgbClr val="333333"/>
+                          </a:solidFill>
+                          <a:latin typeface="Calibri"/>
+                        </a:rPr>
+                        <a:t>Em andamento</a:t>
+                      </a:r>
+                    </a:p>
+                  </a:txBody>
+                  <a:tcPr marL="73152" marR="73152" marT="27432" marB="27432" anchor="ctr">
+                    <a:solidFill>
+                      <a:srgbClr val="F2F2F2"/>
+                    </a:solidFill>
+                  </a:tcPr>
+                </a:tc>
+                <a:tc>
+                  <a:txBody>
+                    <a:bodyPr wrap="square"/>
+                    <a:lstStyle/>
+                    <a:p>
+                      <a:pPr algn="ctr"/>
+                      <a:r>
+                        <a:rPr sz="1200" b="1" i="0">
+                          <a:solidFill>
+                            <a:srgbClr val="FFFFFF"/>
+                          </a:solidFill>
+                          <a:latin typeface="Calibri"/>
+                        </a:rPr>
+                        <a:t>Alto</a:t>
+                      </a:r>
+                    </a:p>
+                  </a:txBody>
+                  <a:tcPr marL="73152" marR="73152" marT="27432" marB="27432" anchor="ctr">
+                    <a:solidFill>
+                      <a:srgbClr val="C62828"/>
+                    </a:solidFill>
+                  </a:tcPr>
+                </a:tc>
+                <a:tc>
+                  <a:txBody>
+                    <a:bodyPr wrap="square"/>
+                    <a:lstStyle/>
+                    <a:p>
+                      <a:pPr algn="r"/>
+                      <a:r>
+                        <a:rPr sz="1200" b="0" i="0">
+                          <a:solidFill>
+                            <a:srgbClr val="333333"/>
+                          </a:solidFill>
+                          <a:latin typeface="Calibri"/>
+                        </a:rPr>
+                        <a:t>34%</a:t>
+                      </a:r>
+                    </a:p>
+                  </a:txBody>
+                  <a:tcPr marL="73152" marR="73152" marT="27432" marB="27432" anchor="ctr">
+                    <a:solidFill>
+                      <a:srgbClr val="F2F2F2"/>
+                    </a:solidFill>
+                  </a:tcPr>
+                </a:tc>
+                <a:tc>
+                  <a:txBody>
+                    <a:bodyPr wrap="square"/>
+                    <a:lstStyle/>
+                    <a:p>
+                      <a:pPr algn="r"/>
+                      <a:r>
+                        <a:rPr sz="1200" b="0" i="0">
+                          <a:solidFill>
+                            <a:srgbClr val="333333"/>
+                          </a:solidFill>
+                          <a:latin typeface="Calibri"/>
+                        </a:rPr>
+                        <a:t>R$ 1,4 mi</a:t>
+                      </a:r>
+                    </a:p>
+                  </a:txBody>
+                  <a:tcPr marL="73152" marR="73152" marT="27432" marB="27432" anchor="ctr">
+                    <a:solidFill>
+                      <a:srgbClr val="F2F2F2"/>
+                    </a:solidFill>
+                  </a:tcPr>
+                </a:tc>
+              </a:tr>
+              <a:tr h="399010">
+                <a:tc>
+                  <a:txBody>
+                    <a:bodyPr wrap="square"/>
+                    <a:lstStyle/>
+                    <a:p>
+                      <a:pPr algn="l"/>
+                      <a:r>
+                        <a:rPr sz="1200" b="0" i="0">
+                          <a:solidFill>
+                            <a:srgbClr val="333333"/>
+                          </a:solidFill>
+                          <a:latin typeface="Calibri"/>
+                        </a:rPr>
+                        <a:t>P-005</a:t>
+                      </a:r>
+                    </a:p>
+                  </a:txBody>
+                  <a:tcPr marL="73152" marR="73152" marT="27432" marB="27432" anchor="ctr">
+                    <a:solidFill>
+                      <a:srgbClr val="FFFFFF"/>
+                    </a:solidFill>
+                  </a:tcPr>
+                </a:tc>
+                <a:tc>
+                  <a:txBody>
+                    <a:bodyPr wrap="square"/>
+                    <a:lstStyle/>
+                    <a:p>
+                      <a:pPr algn="l"/>
+                      <a:r>
+                        <a:rPr sz="1200" b="0" i="0">
+                          <a:solidFill>
+                            <a:srgbClr val="333333"/>
+                          </a:solidFill>
+                          <a:latin typeface="Calibri"/>
+                        </a:rPr>
+                        <a:t>Projeto 5</a:t>
+                      </a:r>
+                    </a:p>
+                  </a:txBody>
+                  <a:tcPr marL="73152" marR="73152" marT="27432" marB="27432" anchor="ctr">
+                    <a:solidFill>
+                      <a:srgbClr val="FFFFFF"/>
+                    </a:solidFill>
+                  </a:tcPr>
+                </a:tc>
+                <a:tc>
+                  <a:txBody>
+                    <a:bodyPr wrap="square"/>
+                    <a:lstStyle/>
+                    <a:p>
+                      <a:pPr algn="l"/>
+                      <a:r>
+                        <a:rPr sz="1200" b="0" i="0">
+                          <a:solidFill>
+                            <a:srgbClr val="333333"/>
+                          </a:solidFill>
+                          <a:latin typeface="Calibri"/>
+                        </a:rPr>
+                        <a:t>Em andamento</a:t>
+                      </a:r>
+                    </a:p>
+                  </a:txBody>
+                  <a:tcPr marL="73152" marR="73152" marT="27432" marB="27432" anchor="ctr">
+                    <a:solidFill>
+                      <a:srgbClr val="FFFFFF"/>
+                    </a:solidFill>
+                  </a:tcPr>
+                </a:tc>
+                <a:tc>
+                  <a:txBody>
+                    <a:bodyPr wrap="square"/>
+                    <a:lstStyle/>
+                    <a:p>
+                      <a:pPr algn="ctr"/>
+                      <a:r>
+                        <a:rPr sz="1200" b="1" i="0">
+                          <a:solidFill>
+                            <a:srgbClr val="FFFFFF"/>
+                          </a:solidFill>
+                          <a:latin typeface="Calibri"/>
+                        </a:rPr>
+                        <a:t>Médio</a:t>
+                      </a:r>
+                    </a:p>
+                  </a:txBody>
+                  <a:tcPr marL="73152" marR="73152" marT="27432" marB="27432" anchor="ctr">
+                    <a:solidFill>
+                      <a:srgbClr val="F9A825"/>
+                    </a:solidFill>
+                  </a:tcPr>
+                </a:tc>
+                <a:tc>
+                  <a:txBody>
+                    <a:bodyPr wrap="square"/>
+                    <a:lstStyle/>
+                    <a:p>
+                      <a:pPr algn="r"/>
+                      <a:r>
+                        <a:rPr sz="1200" b="0" i="0">
+                          <a:solidFill>
+                            <a:srgbClr val="333333"/>
+                          </a:solidFill>
+                          <a:latin typeface="Calibri"/>
+                        </a:rPr>
+                        <a:t>35%</a:t>
+                      </a:r>
+                    </a:p>
+                  </a:txBody>
+                  <a:tcPr marL="73152" marR="73152" marT="27432" marB="27432" anchor="ctr">
+                    <a:solidFill>
+                      <a:srgbClr val="FFFFFF"/>
+                    </a:solidFill>
+                  </a:tcPr>
+                </a:tc>
+                <a:tc>
+                  <a:txBody>
+                    <a:bodyPr wrap="square"/>
+                    <a:lstStyle/>
+                    <a:p>
+                      <a:pPr algn="r"/>
+                      <a:r>
+                        <a:rPr sz="1200" b="0" i="0">
+                          <a:solidFill>
+                            <a:srgbClr val="333333"/>
+                          </a:solidFill>
+                          <a:latin typeface="Calibri"/>
+                        </a:rPr>
+                        <a:t>R$ 1,5 mi</a:t>
+                      </a:r>
+                    </a:p>
+                  </a:txBody>
+                  <a:tcPr marL="73152" marR="73152" marT="27432" marB="27432" anchor="ctr">
+                    <a:solidFill>
+                      <a:srgbClr val="FFFFFF"/>
+                    </a:solidFill>
+                  </a:tcPr>
+                </a:tc>
+              </a:tr>
+              <a:tr h="399010">
+                <a:tc>
+                  <a:txBody>
+                    <a:bodyPr wrap="square"/>
+                    <a:lstStyle/>
+                    <a:p>
+                      <a:pPr algn="l"/>
+                      <a:r>
+                        <a:rPr sz="1200" b="0" i="0">
+                          <a:solidFill>
+                            <a:srgbClr val="333333"/>
+                          </a:solidFill>
+                          <a:latin typeface="Calibri"/>
+                        </a:rPr>
+                        <a:t>P-006</a:t>
+                      </a:r>
+                    </a:p>
+                  </a:txBody>
+                  <a:tcPr marL="73152" marR="73152" marT="27432" marB="27432" anchor="ctr">
+                    <a:solidFill>
+                      <a:srgbClr val="F2F2F2"/>
+                    </a:solidFill>
+                  </a:tcPr>
+                </a:tc>
+                <a:tc>
+                  <a:txBody>
+                    <a:bodyPr wrap="square"/>
+                    <a:lstStyle/>
+                    <a:p>
+                      <a:pPr algn="l"/>
+                      <a:r>
+                        <a:rPr sz="1200" b="0" i="0">
+                          <a:solidFill>
+                            <a:srgbClr val="333333"/>
+                          </a:solidFill>
+                          <a:latin typeface="Calibri"/>
+                        </a:rPr>
+                        <a:t>Projeto 6</a:t>
+                      </a:r>
+                    </a:p>
+                  </a:txBody>
+                  <a:tcPr marL="73152" marR="73152" marT="27432" marB="27432" anchor="ctr">
+                    <a:solidFill>
+                      <a:srgbClr val="F2F2F2"/>
+                    </a:solidFill>
+                  </a:tcPr>
+                </a:tc>
+                <a:tc>
+                  <a:txBody>
+                    <a:bodyPr wrap="square"/>
+                    <a:lstStyle/>
+                    <a:p>
+                      <a:pPr algn="l"/>
+                      <a:r>
+                        <a:rPr sz="1200" b="0" i="0">
+                          <a:solidFill>
+                            <a:srgbClr val="333333"/>
+                          </a:solidFill>
+                          <a:latin typeface="Calibri"/>
+                        </a:rPr>
+                        <a:t>Validação</a:t>
+                      </a:r>
+                    </a:p>
+                  </a:txBody>
+                  <a:tcPr marL="73152" marR="73152" marT="27432" marB="27432" anchor="ctr">
+                    <a:solidFill>
+                      <a:srgbClr val="F2F2F2"/>
+                    </a:solidFill>
+                  </a:tcPr>
+                </a:tc>
+                <a:tc>
+                  <a:txBody>
+                    <a:bodyPr wrap="square"/>
+                    <a:lstStyle/>
+                    <a:p>
+                      <a:pPr algn="ctr"/>
+                      <a:r>
+                        <a:rPr sz="1200" b="1" i="0">
+                          <a:solidFill>
+                            <a:srgbClr val="FFFFFF"/>
+                          </a:solidFill>
+                          <a:latin typeface="Calibri"/>
+                        </a:rPr>
+                        <a:t>Médio</a:t>
+                      </a:r>
+                    </a:p>
+                  </a:txBody>
+                  <a:tcPr marL="73152" marR="73152" marT="27432" marB="27432" anchor="ctr">
+                    <a:solidFill>
+                      <a:srgbClr val="F9A825"/>
+                    </a:solidFill>
+                  </a:tcPr>
+                </a:tc>
+                <a:tc>
+                  <a:txBody>
+                    <a:bodyPr wrap="square"/>
+                    <a:lstStyle/>
+                    <a:p>
+                      <a:pPr algn="r"/>
+                      <a:r>
+                        <a:rPr sz="1200" b="0" i="0">
+                          <a:solidFill>
+                            <a:srgbClr val="333333"/>
+                          </a:solidFill>
+                          <a:latin typeface="Calibri"/>
+                        </a:rPr>
+                        <a:t>36%</a:t>
+                      </a:r>
+                    </a:p>
+                  </a:txBody>
+                  <a:tcPr marL="73152" marR="73152" marT="27432" marB="27432" anchor="ctr">
+                    <a:solidFill>
+                      <a:srgbClr val="F2F2F2"/>
+                    </a:solidFill>
+                  </a:tcPr>
+                </a:tc>
+                <a:tc>
+                  <a:txBody>
+                    <a:bodyPr wrap="square"/>
+                    <a:lstStyle/>
+                    <a:p>
+                      <a:pPr algn="r"/>
+                      <a:r>
+                        <a:rPr sz="1200" b="0" i="0">
+                          <a:solidFill>
+                            <a:srgbClr val="333333"/>
+                          </a:solidFill>
+                          <a:latin typeface="Calibri"/>
+                        </a:rPr>
+                        <a:t>R$ 1,6 mi</a:t>
+                      </a:r>
+                    </a:p>
+                  </a:txBody>
+                  <a:tcPr marL="73152" marR="73152" marT="27432" marB="27432" anchor="ctr">
+                    <a:solidFill>
+                      <a:srgbClr val="F2F2F2"/>
+                    </a:solidFill>
+                  </a:tcPr>
+                </a:tc>
+              </a:tr>
+              <a:tr h="399010">
+                <a:tc>
+                  <a:txBody>
+                    <a:bodyPr wrap="square"/>
+                    <a:lstStyle/>
+                    <a:p>
+                      <a:pPr algn="l"/>
+                      <a:r>
+                        <a:rPr sz="1200" b="0" i="0">
+                          <a:solidFill>
+                            <a:srgbClr val="333333"/>
+                          </a:solidFill>
+                          <a:latin typeface="Calibri"/>
+                        </a:rPr>
+                        <a:t>P-007</a:t>
+                      </a:r>
+                    </a:p>
+                  </a:txBody>
+                  <a:tcPr marL="73152" marR="73152" marT="27432" marB="27432" anchor="ctr">
+                    <a:solidFill>
+                      <a:srgbClr val="FFFFFF"/>
+                    </a:solidFill>
+                  </a:tcPr>
+                </a:tc>
+                <a:tc>
+                  <a:txBody>
+                    <a:bodyPr wrap="square"/>
+                    <a:lstStyle/>
+                    <a:p>
+                      <a:pPr algn="l"/>
+                      <a:r>
+                        <a:rPr sz="1200" b="0" i="0">
+                          <a:solidFill>
+                            <a:srgbClr val="333333"/>
+                          </a:solidFill>
+                          <a:latin typeface="Calibri"/>
+                        </a:rPr>
+                        <a:t>Projeto 7</a:t>
+                      </a:r>
+                    </a:p>
+                  </a:txBody>
+                  <a:tcPr marL="73152" marR="73152" marT="27432" marB="27432" anchor="ctr">
+                    <a:solidFill>
+                      <a:srgbClr val="FFFFFF"/>
+                    </a:solidFill>
+                  </a:tcPr>
+                </a:tc>
+                <a:tc>
+                  <a:txBody>
+                    <a:bodyPr wrap="square"/>
+                    <a:lstStyle/>
+                    <a:p>
+                      <a:pPr algn="l"/>
+                      <a:r>
+                        <a:rPr sz="1200" b="0" i="0">
+                          <a:solidFill>
+                            <a:srgbClr val="333333"/>
+                          </a:solidFill>
+                          <a:latin typeface="Calibri"/>
+                        </a:rPr>
+                        <a:t>Em andamento</a:t>
+                      </a:r>
+                    </a:p>
+                  </a:txBody>
+                  <a:tcPr marL="73152" marR="73152" marT="27432" marB="27432" anchor="ctr">
+                    <a:solidFill>
+                      <a:srgbClr val="FFFFFF"/>
+                    </a:solidFill>
+                  </a:tcPr>
+                </a:tc>
+                <a:tc>
+                  <a:txBody>
+                    <a:bodyPr wrap="square"/>
+                    <a:lstStyle/>
+                    <a:p>
+                      <a:pPr algn="ctr"/>
+                      <a:r>
+                        <a:rPr sz="1200" b="1" i="0">
+                          <a:solidFill>
+                            <a:srgbClr val="FFFFFF"/>
+                          </a:solidFill>
+                          <a:latin typeface="Calibri"/>
+                        </a:rPr>
+                        <a:t>Médio</a:t>
+                      </a:r>
+                    </a:p>
+                  </a:txBody>
+                  <a:tcPr marL="73152" marR="73152" marT="27432" marB="27432" anchor="ctr">
+                    <a:solidFill>
+                      <a:srgbClr val="F9A825"/>
+                    </a:solidFill>
+                  </a:tcPr>
+                </a:tc>
+                <a:tc>
+                  <a:txBody>
+                    <a:bodyPr wrap="square"/>
+                    <a:lstStyle/>
+                    <a:p>
+                      <a:pPr algn="r"/>
+                      <a:r>
+                        <a:rPr sz="1200" b="0" i="0">
+                          <a:solidFill>
+                            <a:srgbClr val="333333"/>
+                          </a:solidFill>
+                          <a:latin typeface="Calibri"/>
+                        </a:rPr>
+                        <a:t>37%</a:t>
+                      </a:r>
+                    </a:p>
+                  </a:txBody>
+                  <a:tcPr marL="73152" marR="73152" marT="27432" marB="27432" anchor="ctr">
+                    <a:solidFill>
+                      <a:srgbClr val="FFFFFF"/>
+                    </a:solidFill>
+                  </a:tcPr>
+                </a:tc>
+                <a:tc>
+                  <a:txBody>
+                    <a:bodyPr wrap="square"/>
+                    <a:lstStyle/>
+                    <a:p>
+                      <a:pPr algn="r"/>
+                      <a:r>
+                        <a:rPr sz="1200" b="0" i="0">
+                          <a:solidFill>
+                            <a:srgbClr val="333333"/>
+                          </a:solidFill>
+                          <a:latin typeface="Calibri"/>
+                        </a:rPr>
+                        <a:t>R$ 1,7 mi</a:t>
+                      </a:r>
+                    </a:p>
+                  </a:txBody>
+                  <a:tcPr marL="73152" marR="73152" marT="27432" marB="27432" anchor="ctr">
+                    <a:solidFill>
+                      <a:srgbClr val="FFFFFF"/>
+                    </a:solidFill>
+                  </a:tcPr>
+                </a:tc>
+              </a:tr>
+              <a:tr h="399010">
+                <a:tc>
+                  <a:txBody>
+                    <a:bodyPr wrap="square"/>
+                    <a:lstStyle/>
+                    <a:p>
+                      <a:pPr algn="l"/>
+                      <a:r>
+                        <a:rPr sz="1200" b="0" i="0">
+                          <a:solidFill>
+                            <a:srgbClr val="333333"/>
+                          </a:solidFill>
+                          <a:latin typeface="Calibri"/>
+                        </a:rPr>
+                        <a:t>P-008</a:t>
+                      </a:r>
+                    </a:p>
+                  </a:txBody>
+                  <a:tcPr marL="73152" marR="73152" marT="27432" marB="27432" anchor="ctr">
+                    <a:solidFill>
+                      <a:srgbClr val="F2F2F2"/>
+                    </a:solidFill>
+                  </a:tcPr>
+                </a:tc>
+                <a:tc>
+                  <a:txBody>
+                    <a:bodyPr wrap="square"/>
+                    <a:lstStyle/>
+                    <a:p>
+                      <a:pPr algn="l"/>
+                      <a:r>
+                        <a:rPr sz="1200" b="0" i="0">
+                          <a:solidFill>
+                            <a:srgbClr val="333333"/>
+                          </a:solidFill>
+                          <a:latin typeface="Calibri"/>
+                        </a:rPr>
+                        <a:t>Projeto 8</a:t>
+                      </a:r>
+                    </a:p>
+                  </a:txBody>
+                  <a:tcPr marL="73152" marR="73152" marT="27432" marB="27432" anchor="ctr">
+                    <a:solidFill>
+                      <a:srgbClr val="F2F2F2"/>
+                    </a:solidFill>
+                  </a:tcPr>
+                </a:tc>
+                <a:tc>
+                  <a:txBody>
+                    <a:bodyPr wrap="square"/>
+                    <a:lstStyle/>
+                    <a:p>
+                      <a:pPr algn="l"/>
+                      <a:r>
+                        <a:rPr sz="1200" b="0" i="0">
+                          <a:solidFill>
+                            <a:srgbClr val="333333"/>
+                          </a:solidFill>
+                          <a:latin typeface="Calibri"/>
+                        </a:rPr>
+                        <a:t>Em andamento</a:t>
+                      </a:r>
+                    </a:p>
+                  </a:txBody>
+                  <a:tcPr marL="73152" marR="73152" marT="27432" marB="27432" anchor="ctr">
+                    <a:solidFill>
+                      <a:srgbClr val="F2F2F2"/>
+                    </a:solidFill>
+                  </a:tcPr>
+                </a:tc>
+                <a:tc>
+                  <a:txBody>
+                    <a:bodyPr wrap="square"/>
+                    <a:lstStyle/>
+                    <a:p>
+                      <a:pPr algn="ctr"/>
+                      <a:r>
+                        <a:rPr sz="1200" b="1" i="0">
+                          <a:solidFill>
+                            <a:srgbClr val="FFFFFF"/>
+                          </a:solidFill>
+                          <a:latin typeface="Calibri"/>
+                        </a:rPr>
+                        <a:t>Alto</a:t>
+                      </a:r>
+                    </a:p>
+                  </a:txBody>
+                  <a:tcPr marL="73152" marR="73152" marT="27432" marB="27432" anchor="ctr">
+                    <a:solidFill>
+                      <a:srgbClr val="C62828"/>
+                    </a:solidFill>
+                  </a:tcPr>
+                </a:tc>
+                <a:tc>
+                  <a:txBody>
+                    <a:bodyPr wrap="square"/>
+                    <a:lstStyle/>
+                    <a:p>
+                      <a:pPr algn="r"/>
+                      <a:r>
+                        <a:rPr sz="1200" b="0" i="0">
+                          <a:solidFill>
+                            <a:srgbClr val="333333"/>
+                          </a:solidFill>
+                          <a:latin typeface="Calibri"/>
+                        </a:rPr>
+                        <a:t>38%</a:t>
+                      </a:r>
+                    </a:p>
+                  </a:txBody>
+                  <a:tcPr marL="73152" marR="73152" marT="27432" marB="27432" anchor="ctr">
+                    <a:solidFill>
+                      <a:srgbClr val="F2F2F2"/>
+                    </a:solidFill>
+                  </a:tcPr>
+                </a:tc>
+                <a:tc>
+                  <a:txBody>
+                    <a:bodyPr wrap="square"/>
+                    <a:lstStyle/>
+                    <a:p>
+                      <a:pPr algn="r"/>
+                      <a:r>
+                        <a:rPr sz="1200" b="0" i="0">
+                          <a:solidFill>
+                            <a:srgbClr val="333333"/>
+                          </a:solidFill>
+                          <a:latin typeface="Calibri"/>
+                        </a:rPr>
+                        <a:t>R$ 1,8 mi</a:t>
+                      </a:r>
+                    </a:p>
+                  </a:txBody>
+                  <a:tcPr marL="73152" marR="73152" marT="27432" marB="27432" anchor="ctr">
+                    <a:solidFill>
+                      <a:srgbClr val="F2F2F2"/>
+                    </a:solidFill>
+                  </a:tcPr>
+                </a:tc>
+              </a:tr>
+              <a:tr h="399010">
+                <a:tc>
+                  <a:txBody>
+                    <a:bodyPr wrap="square"/>
+                    <a:lstStyle/>
+                    <a:p>
+                      <a:pPr algn="l"/>
+                      <a:r>
+                        <a:rPr sz="1200" b="0" i="0">
+                          <a:solidFill>
+                            <a:srgbClr val="333333"/>
+                          </a:solidFill>
+                          <a:latin typeface="Calibri"/>
+                        </a:rPr>
+                        <a:t>P-009</a:t>
+                      </a:r>
+                    </a:p>
+                  </a:txBody>
+                  <a:tcPr marL="73152" marR="73152" marT="27432" marB="27432" anchor="ctr">
+                    <a:solidFill>
+                      <a:srgbClr val="FFFFFF"/>
+                    </a:solidFill>
+                  </a:tcPr>
+                </a:tc>
+                <a:tc>
+                  <a:txBody>
+                    <a:bodyPr wrap="square"/>
+                    <a:lstStyle/>
+                    <a:p>
+                      <a:pPr algn="l"/>
+                      <a:r>
+                        <a:rPr sz="1200" b="0" i="0">
+                          <a:solidFill>
+                            <a:srgbClr val="333333"/>
+                          </a:solidFill>
+                          <a:latin typeface="Calibri"/>
+                        </a:rPr>
+                        <a:t>Projeto 9</a:t>
+                      </a:r>
+                    </a:p>
+                  </a:txBody>
+                  <a:tcPr marL="73152" marR="73152" marT="27432" marB="27432" anchor="ctr">
+                    <a:solidFill>
+                      <a:srgbClr val="FFFFFF"/>
+                    </a:solidFill>
+                  </a:tcPr>
+                </a:tc>
+                <a:tc>
+                  <a:txBody>
+                    <a:bodyPr wrap="square"/>
+                    <a:lstStyle/>
+                    <a:p>
+                      <a:pPr algn="l"/>
+                      <a:r>
+                        <a:rPr sz="1200" b="0" i="0">
+                          <a:solidFill>
+                            <a:srgbClr val="333333"/>
+                          </a:solidFill>
+                          <a:latin typeface="Calibri"/>
+                        </a:rPr>
+                        <a:t>Validação</a:t>
+                      </a:r>
+                    </a:p>
+                  </a:txBody>
+                  <a:tcPr marL="73152" marR="73152" marT="27432" marB="27432" anchor="ctr">
+                    <a:solidFill>
+                      <a:srgbClr val="FFFFFF"/>
+                    </a:solidFill>
+                  </a:tcPr>
+                </a:tc>
+                <a:tc>
+                  <a:txBody>
+                    <a:bodyPr wrap="square"/>
+                    <a:lstStyle/>
+                    <a:p>
+                      <a:pPr algn="ctr"/>
+                      <a:r>
+                        <a:rPr sz="1200" b="1" i="0">
+                          <a:solidFill>
+                            <a:srgbClr val="FFFFFF"/>
+                          </a:solidFill>
+                          <a:latin typeface="Calibri"/>
+                        </a:rPr>
+                        <a:t>Médio</a:t>
+                      </a:r>
+                    </a:p>
+                  </a:txBody>
+                  <a:tcPr marL="73152" marR="73152" marT="27432" marB="27432" anchor="ctr">
+                    <a:solidFill>
+                      <a:srgbClr val="F9A825"/>
+                    </a:solidFill>
+                  </a:tcPr>
+                </a:tc>
+                <a:tc>
+                  <a:txBody>
+                    <a:bodyPr wrap="square"/>
+                    <a:lstStyle/>
+                    <a:p>
+                      <a:pPr algn="r"/>
+                      <a:r>
+                        <a:rPr sz="1200" b="0" i="0">
+                          <a:solidFill>
+                            <a:srgbClr val="333333"/>
+                          </a:solidFill>
+                          <a:latin typeface="Calibri"/>
+                        </a:rPr>
+                        <a:t>39%</a:t>
+                      </a:r>
+                    </a:p>
+                  </a:txBody>
+                  <a:tcPr marL="73152" marR="73152" marT="27432" marB="27432" anchor="ctr">
+                    <a:solidFill>
+                      <a:srgbClr val="FFFFFF"/>
+                    </a:solidFill>
+                  </a:tcPr>
+                </a:tc>
+                <a:tc>
+                  <a:txBody>
+                    <a:bodyPr wrap="square"/>
+                    <a:lstStyle/>
+                    <a:p>
+                      <a:pPr algn="r"/>
+                      <a:r>
+                        <a:rPr sz="1200" b="0" i="0">
+                          <a:solidFill>
+                            <a:srgbClr val="333333"/>
+                          </a:solidFill>
+                          <a:latin typeface="Calibri"/>
+                        </a:rPr>
+                        <a:t>R$ 1,9 mi</a:t>
+                      </a:r>
+                    </a:p>
+                  </a:txBody>
+                  <a:tcPr marL="73152" marR="73152" marT="27432" marB="27432" anchor="ctr">
+                    <a:solidFill>
+                      <a:srgbClr val="FFFFFF"/>
+                    </a:solidFill>
+                  </a:tcPr>
+                </a:tc>
+              </a:tr>
+              <a:tr h="399020">
+                <a:tc>
+                  <a:txBody>
+                    <a:bodyPr wrap="square"/>
+                    <a:lstStyle/>
+                    <a:p>
+                      <a:pPr algn="l"/>
+                      <a:r>
+                        <a:rPr sz="1200" b="0" i="0">
+                          <a:solidFill>
+                            <a:srgbClr val="333333"/>
+                          </a:solidFill>
+                          <a:latin typeface="Calibri"/>
+                        </a:rPr>
+                        <a:t>P-010</a:t>
+                      </a:r>
+                    </a:p>
+                  </a:txBody>
+                  <a:tcPr marL="73152" marR="73152" marT="27432" marB="27432" anchor="ctr">
+                    <a:solidFill>
+                      <a:srgbClr val="F2F2F2"/>
+                    </a:solidFill>
+                  </a:tcPr>
+                </a:tc>
+                <a:tc>
+                  <a:txBody>
+                    <a:bodyPr wrap="square"/>
+                    <a:lstStyle/>
+                    <a:p>
+                      <a:pPr algn="l"/>
+                      <a:r>
+                        <a:rPr sz="1200" b="0" i="0">
+                          <a:solidFill>
+                            <a:srgbClr val="333333"/>
+                          </a:solidFill>
+                          <a:latin typeface="Calibri"/>
+                        </a:rPr>
+                        <a:t>Projeto 10</a:t>
+                      </a:r>
+                    </a:p>
+                  </a:txBody>
+                  <a:tcPr marL="73152" marR="73152" marT="27432" marB="27432" anchor="ctr">
+                    <a:solidFill>
+                      <a:srgbClr val="F2F2F2"/>
+                    </a:solidFill>
+                  </a:tcPr>
+                </a:tc>
+                <a:tc>
+                  <a:txBody>
+                    <a:bodyPr wrap="square"/>
+                    <a:lstStyle/>
+                    <a:p>
+                      <a:pPr algn="l"/>
+                      <a:r>
+                        <a:rPr sz="1200" b="0" i="0">
+                          <a:solidFill>
+                            <a:srgbClr val="333333"/>
+                          </a:solidFill>
+                          <a:latin typeface="Calibri"/>
+                        </a:rPr>
+                        <a:t>Em andamento</a:t>
+                      </a:r>
+                    </a:p>
+                  </a:txBody>
+                  <a:tcPr marL="73152" marR="73152" marT="27432" marB="27432" anchor="ctr">
+                    <a:solidFill>
+                      <a:srgbClr val="F2F2F2"/>
+                    </a:solidFill>
+                  </a:tcPr>
+                </a:tc>
+                <a:tc>
+                  <a:txBody>
+                    <a:bodyPr wrap="square"/>
+                    <a:lstStyle/>
+                    <a:p>
+                      <a:pPr algn="ctr"/>
+                      <a:r>
+                        <a:rPr sz="1200" b="1" i="0">
+                          <a:solidFill>
+                            <a:srgbClr val="FFFFFF"/>
+                          </a:solidFill>
+                          <a:latin typeface="Calibri"/>
+                        </a:rPr>
+                        <a:t>Médio</a:t>
+                      </a:r>
+                    </a:p>
+                  </a:txBody>
+                  <a:tcPr marL="73152" marR="73152" marT="27432" marB="27432" anchor="ctr">
+                    <a:solidFill>
+                      <a:srgbClr val="F9A825"/>
+                    </a:solidFill>
+                  </a:tcPr>
+                </a:tc>
+                <a:tc>
+                  <a:txBody>
+                    <a:bodyPr wrap="square"/>
+                    <a:lstStyle/>
+                    <a:p>
+                      <a:pPr algn="r"/>
+                      <a:r>
+                        <a:rPr sz="1200" b="0" i="0">
+                          <a:solidFill>
+                            <a:srgbClr val="333333"/>
+                          </a:solidFill>
+                          <a:latin typeface="Calibri"/>
+                        </a:rPr>
+                        <a:t>40%</a:t>
+                      </a:r>
+                    </a:p>
+                  </a:txBody>
+                  <a:tcPr marL="73152" marR="73152" marT="27432" marB="27432" anchor="ctr">
+                    <a:solidFill>
+                      <a:srgbClr val="F2F2F2"/>
+                    </a:solidFill>
+                  </a:tcPr>
+                </a:tc>
+                <a:tc>
+                  <a:txBody>
+                    <a:bodyPr wrap="square"/>
+                    <a:lstStyle/>
+                    <a:p>
+                      <a:pPr algn="r"/>
+                      <a:r>
+                        <a:rPr sz="1200" b="0" i="0">
+                          <a:solidFill>
+                            <a:srgbClr val="333333"/>
+                          </a:solidFill>
+                          <a:latin typeface="Calibri"/>
+                        </a:rPr>
+                        <a:t>R$ 2,0 mi</a:t>
+                      </a:r>
+                    </a:p>
+                  </a:txBody>
+                  <a:tcPr marL="73152" marR="73152" marT="27432" marB="27432" anchor="ctr">
+                    <a:solidFill>
+                      <a:srgbClr val="F2F2F2"/>
+                    </a:solidFill>
+                  </a:tcPr>
+                </a:tc>
+              </a:tr>
+            </a:tbl>
+          </a:graphicData>
+        </a:graphic>
+      </p:graphicFrame>
+    </p:spTree>
+  </p:cSld>
+  <p:clrMapOvr>
+    <a:masterClrMapping/>
+  </p:clrMapOvr>
+</p:sld>
+</file>
+
+<file path=ppt/slides/slide33.xml><?xml version="1.0" encoding="utf-8"?>
+<p:sld xmlns:a="http://schemas.openxmlformats.org/drawingml/2006/main" xmlns:p="http://schemas.openxmlformats.org/presentationml/2006/main" xmlns:r="http://schemas.openxmlformats.org/officeDocument/2006/relationships">
+  <p:cSld>
+    <p:spTree>
+      <p:nvGrpSpPr>
+        <p:cNvPr id="1" name=""/>
+        <p:cNvGrpSpPr/>
+        <p:nvPr/>
+      </p:nvGrpSpPr>
+      <p:grpSpPr/>
+      <p:sp>
+        <p:nvSpPr>
+          <p:cNvPr id="2" name="Title 1"/>
+          <p:cNvSpPr>
+            <a:spLocks noGrp="1"/>
+          </p:cNvSpPr>
+          <p:nvPr>
+            <p:ph type="title"/>
+          </p:nvPr>
+        </p:nvSpPr>
+        <p:spPr>
+          <a:xfrm>
+            <a:off x="457200" y="621792"/>
+            <a:ext cx="11274552" cy="822960"/>
+          </a:xfrm>
+        </p:spPr>
+        <p:txBody>
+          <a:bodyPr wrap="square" anchor="t" lIns="45720" rIns="45720"/>
+          <a:lstStyle/>
+          <a:p>
+            <a:pPr algn="l"/>
+            <a:r>
+              <a:rPr sz="2800" b="1" i="0">
+                <a:solidFill>
+                  <a:srgbClr val="1F3A5F"/>
+                </a:solidFill>
+                <a:latin typeface="Calibri"/>
+              </a:rPr>
+              <a:t>Tabela longa paginada automaticamente (25 linhas) (2/3)</a:t>
+            </a:r>
+          </a:p>
+        </p:txBody>
+      </p:sp>
+      <p:sp>
+        <p:nvSpPr>
+          <p:cNvPr id="3" name="TextBox 2"/>
+          <p:cNvSpPr txBox="1"/>
+          <p:nvPr/>
+        </p:nvSpPr>
+        <p:spPr>
+          <a:xfrm>
+            <a:off x="457200" y="91440"/>
+            <a:ext cx="7315200" cy="228600"/>
+          </a:xfrm>
+          <a:prstGeom prst="rect">
+            <a:avLst/>
+          </a:prstGeom>
+          <a:noFill/>
+        </p:spPr>
+        <p:txBody>
+          <a:bodyPr wrap="square" anchor="ctr" lIns="45720" rIns="45720" tIns="27432" bIns="27432">
+            <a:spAutoFit/>
+          </a:bodyPr>
+          <a:lstStyle/>
+          <a:p>
+            <a:pPr algn="l"/>
+            <a:r>
+              <a:rPr sz="900" b="1" i="0">
+                <a:solidFill>
+                  <a:srgbClr val="8C8C8C"/>
+                </a:solidFill>
+                <a:latin typeface="Calibri"/>
+              </a:rPr>
+              <a:t>EMPRESA EXEMPLO  |  CATÁLOGO DE MODELOS</a:t>
+            </a:r>
+          </a:p>
+        </p:txBody>
+      </p:sp>
+      <p:sp>
+        <p:nvSpPr>
+          <p:cNvPr id="4" name="TextBox 3"/>
+          <p:cNvSpPr txBox="1"/>
+          <p:nvPr/>
+        </p:nvSpPr>
+        <p:spPr>
+          <a:xfrm>
+            <a:off x="7772400" y="91440"/>
+            <a:ext cx="3959352" cy="228600"/>
+          </a:xfrm>
+          <a:prstGeom prst="rect">
+            <a:avLst/>
+          </a:prstGeom>
+          <a:noFill/>
+        </p:spPr>
+        <p:txBody>
+          <a:bodyPr wrap="square" anchor="ctr" lIns="45720" rIns="45720" tIns="27432" bIns="27432">
+            <a:spAutoFit/>
+          </a:bodyPr>
+          <a:lstStyle/>
+          <a:p>
+            <a:pPr algn="r"/>
+            <a:r>
+              <a:rPr sz="900" b="0" i="0">
+                <a:solidFill>
+                  <a:srgbClr val="8C8C8C"/>
+                </a:solidFill>
+                <a:latin typeface="Calibri"/>
+              </a:rPr>
+              <a:t>set/2026</a:t>
+            </a:r>
+          </a:p>
+        </p:txBody>
+      </p:sp>
+      <p:sp>
+        <p:nvSpPr>
+          <p:cNvPr id="5" name="TextBox 4"/>
+          <p:cNvSpPr txBox="1"/>
+          <p:nvPr/>
+        </p:nvSpPr>
+        <p:spPr>
+          <a:xfrm>
+            <a:off x="457200" y="384048"/>
+            <a:ext cx="11274552" cy="256032"/>
+          </a:xfrm>
+          <a:prstGeom prst="rect">
+            <a:avLst/>
+          </a:prstGeom>
+          <a:noFill/>
+        </p:spPr>
+        <p:txBody>
+          <a:bodyPr wrap="square" anchor="b" lIns="45720" rIns="45720" tIns="27432" bIns="27432">
+            <a:spAutoFit/>
+          </a:bodyPr>
+          <a:lstStyle/>
+          <a:p>
+            <a:pPr algn="l"/>
+            <a:r>
+              <a:rPr sz="1000" b="1" i="0">
+                <a:solidFill>
+                  <a:srgbClr val="4F81BD"/>
+                </a:solidFill>
+                <a:latin typeface="Calibri"/>
+              </a:rPr>
+              <a:t>ANEXO</a:t>
+            </a:r>
+          </a:p>
+        </p:txBody>
+      </p:sp>
+      <p:sp>
+        <p:nvSpPr>
+          <p:cNvPr id="6" name="TextBox 5"/>
+          <p:cNvSpPr txBox="1"/>
+          <p:nvPr/>
+        </p:nvSpPr>
+        <p:spPr>
+          <a:xfrm>
+            <a:off x="457200" y="6217920"/>
+            <a:ext cx="8531352" cy="365760"/>
+          </a:xfrm>
+          <a:prstGeom prst="rect">
+            <a:avLst/>
+          </a:prstGeom>
+          <a:noFill/>
+        </p:spPr>
+        <p:txBody>
+          <a:bodyPr wrap="square" anchor="ctr" lIns="45720" rIns="45720" tIns="27432" bIns="27432">
+            <a:spAutoFit/>
+          </a:bodyPr>
+          <a:lstStyle/>
+          <a:p>
+            <a:pPr algn="l"/>
+            <a:r>
+              <a:rPr sz="1000" b="0" i="0">
+                <a:solidFill>
+                  <a:srgbClr val="8C8C8C"/>
+                </a:solidFill>
+                <a:latin typeface="Calibri"/>
+              </a:rPr>
+              <a:t>Fonte: Base de portfólio (exemplo)   |   Uso interno</a:t>
+            </a:r>
+          </a:p>
+        </p:txBody>
+      </p:sp>
+      <p:sp>
+        <p:nvSpPr>
+          <p:cNvPr id="7" name="TextBox 6"/>
+          <p:cNvSpPr txBox="1"/>
+          <p:nvPr/>
+        </p:nvSpPr>
+        <p:spPr>
+          <a:xfrm>
+            <a:off x="10817352" y="6217920"/>
+            <a:ext cx="914400" cy="365760"/>
+          </a:xfrm>
+          <a:prstGeom prst="rect">
+            <a:avLst/>
+          </a:prstGeom>
+          <a:noFill/>
+        </p:spPr>
+        <p:txBody>
+          <a:bodyPr wrap="square" anchor="ctr" lIns="45720" rIns="45720" tIns="27432" bIns="27432">
+            <a:spAutoFit/>
+          </a:bodyPr>
+          <a:lstStyle/>
+          <a:p>
+            <a:pPr algn="r"/>
+            <a:r>
+              <a:rPr sz="1000" b="0" i="0">
+                <a:solidFill>
+                  <a:srgbClr val="8C8C8C"/>
+                </a:solidFill>
+                <a:latin typeface="Calibri"/>
+              </a:rPr>
+              <a:t>33</a:t>
+            </a:r>
+          </a:p>
+        </p:txBody>
+      </p:sp>
+      <p:pic>
+        <p:nvPicPr>
+          <p:cNvPr id="8" name="Picture 7" descr="logo-placeholder.png"/>
+          <p:cNvPicPr>
+            <a:picLocks noChangeAspect="1"/>
+          </p:cNvPicPr>
+          <p:nvPr/>
+        </p:nvPicPr>
+        <p:blipFill>
+          <a:blip r:embed="rId2"/>
+          <a:stretch>
+            <a:fillRect/>
+          </a:stretch>
+        </p:blipFill>
+        <p:spPr>
+          <a:xfrm>
+            <a:off x="9692640" y="6245352"/>
+            <a:ext cx="822960" cy="274320"/>
+          </a:xfrm>
+          <a:prstGeom prst="rect">
+            <a:avLst/>
+          </a:prstGeom>
+        </p:spPr>
+      </p:pic>
+      <p:graphicFrame>
+        <p:nvGraphicFramePr>
+          <p:cNvPr id="9" name="Table 8"/>
+          <p:cNvGraphicFramePr>
+            <a:graphicFrameLocks noGrp="1"/>
+          </p:cNvGraphicFramePr>
+          <p:nvPr/>
+        </p:nvGraphicFramePr>
+        <p:xfrm>
+          <a:off x="457200" y="1737360"/>
+          <a:ext cx="11274552" cy="4389120"/>
+        </p:xfrm>
+        <a:graphic>
+          <a:graphicData uri="http://schemas.openxmlformats.org/drawingml/2006/table">
+            <a:tbl>
+              <a:tblPr firstRow="1">
+                <a:tableStyleId>{5C22544A-7EE6-4342-B048-85BDC9FD1C3A}</a:tableStyleId>
+              </a:tblPr>
+              <a:tblGrid>
+                <a:gridCol w="1879092"/>
+                <a:gridCol w="1879092"/>
+                <a:gridCol w="1879092"/>
+                <a:gridCol w="1879092"/>
+                <a:gridCol w="1879092"/>
+                <a:gridCol w="1879092"/>
+              </a:tblGrid>
+              <a:tr h="399010">
+                <a:tc>
+                  <a:txBody>
+                    <a:bodyPr wrap="square"/>
+                    <a:lstStyle/>
+                    <a:p>
+                      <a:pPr algn="l"/>
+                      <a:r>
+                        <a:rPr sz="1200" b="1" i="0">
+                          <a:solidFill>
+                            <a:srgbClr val="FFFFFF"/>
+                          </a:solidFill>
+                          <a:latin typeface="Calibri"/>
+                        </a:rPr>
+                        <a:t>ID</a:t>
+                      </a:r>
+                    </a:p>
+                  </a:txBody>
+                  <a:tcPr marL="73152" marR="73152" marT="27432" marB="27432" anchor="ctr">
+                    <a:solidFill>
+                      <a:srgbClr val="1F3A5F"/>
+                    </a:solidFill>
+                  </a:tcPr>
+                </a:tc>
+                <a:tc>
+                  <a:txBody>
+                    <a:bodyPr wrap="square"/>
+                    <a:lstStyle/>
+                    <a:p>
+                      <a:pPr algn="l"/>
+                      <a:r>
+                        <a:rPr sz="1200" b="1" i="0">
+                          <a:solidFill>
+                            <a:srgbClr val="FFFFFF"/>
+                          </a:solidFill>
+                          <a:latin typeface="Calibri"/>
+                        </a:rPr>
+                        <a:t>Projeto</a:t>
+                      </a:r>
+                    </a:p>
+                  </a:txBody>
+                  <a:tcPr marL="73152" marR="73152" marT="27432" marB="27432" anchor="ctr">
+                    <a:solidFill>
+                      <a:srgbClr val="1F3A5F"/>
+                    </a:solidFill>
+                  </a:tcPr>
+                </a:tc>
+                <a:tc>
+                  <a:txBody>
+                    <a:bodyPr wrap="square"/>
+                    <a:lstStyle/>
+                    <a:p>
+                      <a:pPr algn="l"/>
+                      <a:r>
+                        <a:rPr sz="1200" b="1" i="0">
+                          <a:solidFill>
+                            <a:srgbClr val="FFFFFF"/>
+                          </a:solidFill>
+                          <a:latin typeface="Calibri"/>
+                        </a:rPr>
+                        <a:t>Status</a:t>
+                      </a:r>
+                    </a:p>
+                  </a:txBody>
+                  <a:tcPr marL="73152" marR="73152" marT="27432" marB="27432" anchor="ctr">
+                    <a:solidFill>
+                      <a:srgbClr val="1F3A5F"/>
+                    </a:solidFill>
+                  </a:tcPr>
+                </a:tc>
+                <a:tc>
+                  <a:txBody>
+                    <a:bodyPr wrap="square"/>
+                    <a:lstStyle/>
+                    <a:p>
+                      <a:pPr algn="ctr"/>
+                      <a:r>
+                        <a:rPr sz="1200" b="1" i="0">
+                          <a:solidFill>
+                            <a:srgbClr val="FFFFFF"/>
+                          </a:solidFill>
+                          <a:latin typeface="Calibri"/>
+                        </a:rPr>
+                        <a:t>Risco</a:t>
+                      </a:r>
+                    </a:p>
+                  </a:txBody>
+                  <a:tcPr marL="73152" marR="73152" marT="27432" marB="27432" anchor="ctr">
+                    <a:solidFill>
+                      <a:srgbClr val="1F3A5F"/>
+                    </a:solidFill>
+                  </a:tcPr>
+                </a:tc>
+                <a:tc>
+                  <a:txBody>
+                    <a:bodyPr wrap="square"/>
+                    <a:lstStyle/>
+                    <a:p>
+                      <a:pPr algn="r"/>
+                      <a:r>
+                        <a:rPr sz="1200" b="1" i="0">
+                          <a:solidFill>
+                            <a:srgbClr val="FFFFFF"/>
+                          </a:solidFill>
+                          <a:latin typeface="Calibri"/>
+                        </a:rPr>
+                        <a:t>Conclusão</a:t>
+                      </a:r>
+                    </a:p>
+                  </a:txBody>
+                  <a:tcPr marL="73152" marR="73152" marT="27432" marB="27432" anchor="ctr">
+                    <a:solidFill>
+                      <a:srgbClr val="1F3A5F"/>
+                    </a:solidFill>
+                  </a:tcPr>
+                </a:tc>
+                <a:tc>
+                  <a:txBody>
+                    <a:bodyPr wrap="square"/>
+                    <a:lstStyle/>
+                    <a:p>
+                      <a:pPr algn="r"/>
+                      <a:r>
+                        <a:rPr sz="1200" b="1" i="0">
+                          <a:solidFill>
+                            <a:srgbClr val="FFFFFF"/>
+                          </a:solidFill>
+                          <a:latin typeface="Calibri"/>
+                        </a:rPr>
+                        <a:t>Orçamento</a:t>
+                      </a:r>
+                    </a:p>
+                  </a:txBody>
+                  <a:tcPr marL="73152" marR="73152" marT="27432" marB="27432" anchor="ctr">
+                    <a:solidFill>
+                      <a:srgbClr val="1F3A5F"/>
+                    </a:solidFill>
+                  </a:tcPr>
+                </a:tc>
+              </a:tr>
+              <a:tr h="399010">
+                <a:tc>
+                  <a:txBody>
+                    <a:bodyPr wrap="square"/>
+                    <a:lstStyle/>
+                    <a:p>
+                      <a:pPr algn="l"/>
+                      <a:r>
+                        <a:rPr sz="1200" b="0" i="0">
+                          <a:solidFill>
+                            <a:srgbClr val="333333"/>
+                          </a:solidFill>
+                          <a:latin typeface="Calibri"/>
+                        </a:rPr>
+                        <a:t>P-011</a:t>
+                      </a:r>
+                    </a:p>
+                  </a:txBody>
+                  <a:tcPr marL="73152" marR="73152" marT="27432" marB="27432" anchor="ctr">
+                    <a:solidFill>
+                      <a:srgbClr val="FFFFFF"/>
+                    </a:solidFill>
+                  </a:tcPr>
+                </a:tc>
+                <a:tc>
+                  <a:txBody>
+                    <a:bodyPr wrap="square"/>
+                    <a:lstStyle/>
+                    <a:p>
+                      <a:pPr algn="l"/>
+                      <a:r>
+                        <a:rPr sz="1200" b="0" i="0">
+                          <a:solidFill>
+                            <a:srgbClr val="333333"/>
+                          </a:solidFill>
+                          <a:latin typeface="Calibri"/>
+                        </a:rPr>
+                        <a:t>Projeto 11</a:t>
+                      </a:r>
+                    </a:p>
+                  </a:txBody>
+                  <a:tcPr marL="73152" marR="73152" marT="27432" marB="27432" anchor="ctr">
+                    <a:solidFill>
+                      <a:srgbClr val="FFFFFF"/>
+                    </a:solidFill>
+                  </a:tcPr>
+                </a:tc>
+                <a:tc>
+                  <a:txBody>
+                    <a:bodyPr wrap="square"/>
+                    <a:lstStyle/>
+                    <a:p>
+                      <a:pPr algn="l"/>
+                      <a:r>
+                        <a:rPr sz="1200" b="0" i="0">
+                          <a:solidFill>
+                            <a:srgbClr val="333333"/>
+                          </a:solidFill>
+                          <a:latin typeface="Calibri"/>
+                        </a:rPr>
+                        <a:t>Em andamento</a:t>
+                      </a:r>
+                    </a:p>
+                  </a:txBody>
+                  <a:tcPr marL="73152" marR="73152" marT="27432" marB="27432" anchor="ctr">
+                    <a:solidFill>
+                      <a:srgbClr val="FFFFFF"/>
+                    </a:solidFill>
+                  </a:tcPr>
+                </a:tc>
+                <a:tc>
+                  <a:txBody>
+                    <a:bodyPr wrap="square"/>
+                    <a:lstStyle/>
+                    <a:p>
+                      <a:pPr algn="ctr"/>
+                      <a:r>
+                        <a:rPr sz="1200" b="1" i="0">
+                          <a:solidFill>
+                            <a:srgbClr val="FFFFFF"/>
+                          </a:solidFill>
+                          <a:latin typeface="Calibri"/>
+                        </a:rPr>
+                        <a:t>Médio</a:t>
+                      </a:r>
+                    </a:p>
+                  </a:txBody>
+                  <a:tcPr marL="73152" marR="73152" marT="27432" marB="27432" anchor="ctr">
+                    <a:solidFill>
+                      <a:srgbClr val="F9A825"/>
+                    </a:solidFill>
+                  </a:tcPr>
+                </a:tc>
+                <a:tc>
+                  <a:txBody>
+                    <a:bodyPr wrap="square"/>
+                    <a:lstStyle/>
+                    <a:p>
+                      <a:pPr algn="r"/>
+                      <a:r>
+                        <a:rPr sz="1200" b="0" i="0">
+                          <a:solidFill>
+                            <a:srgbClr val="333333"/>
+                          </a:solidFill>
+                          <a:latin typeface="Calibri"/>
+                        </a:rPr>
+                        <a:t>41%</a:t>
+                      </a:r>
+                    </a:p>
+                  </a:txBody>
+                  <a:tcPr marL="73152" marR="73152" marT="27432" marB="27432" anchor="ctr">
+                    <a:solidFill>
+                      <a:srgbClr val="FFFFFF"/>
+                    </a:solidFill>
+                  </a:tcPr>
+                </a:tc>
+                <a:tc>
+                  <a:txBody>
+                    <a:bodyPr wrap="square"/>
+                    <a:lstStyle/>
+                    <a:p>
+                      <a:pPr algn="r"/>
+                      <a:r>
+                        <a:rPr sz="1200" b="0" i="0">
+                          <a:solidFill>
+                            <a:srgbClr val="333333"/>
+                          </a:solidFill>
+                          <a:latin typeface="Calibri"/>
+                        </a:rPr>
+                        <a:t>R$ 2,1 mi</a:t>
+                      </a:r>
+                    </a:p>
+                  </a:txBody>
+                  <a:tcPr marL="73152" marR="73152" marT="27432" marB="27432" anchor="ctr">
+                    <a:solidFill>
+                      <a:srgbClr val="FFFFFF"/>
+                    </a:solidFill>
+                  </a:tcPr>
+                </a:tc>
+              </a:tr>
+              <a:tr h="399010">
+                <a:tc>
+                  <a:txBody>
+                    <a:bodyPr wrap="square"/>
+                    <a:lstStyle/>
+                    <a:p>
+                      <a:pPr algn="l"/>
+                      <a:r>
+                        <a:rPr sz="1200" b="0" i="0">
+                          <a:solidFill>
+                            <a:srgbClr val="333333"/>
+                          </a:solidFill>
+                          <a:latin typeface="Calibri"/>
+                        </a:rPr>
+                        <a:t>P-012</a:t>
+                      </a:r>
+                    </a:p>
+                  </a:txBody>
+                  <a:tcPr marL="73152" marR="73152" marT="27432" marB="27432" anchor="ctr">
+                    <a:solidFill>
+                      <a:srgbClr val="F2F2F2"/>
+                    </a:solidFill>
+                  </a:tcPr>
+                </a:tc>
+                <a:tc>
+                  <a:txBody>
+                    <a:bodyPr wrap="square"/>
+                    <a:lstStyle/>
+                    <a:p>
+                      <a:pPr algn="l"/>
+                      <a:r>
+                        <a:rPr sz="1200" b="0" i="0">
+                          <a:solidFill>
+                            <a:srgbClr val="333333"/>
+                          </a:solidFill>
+                          <a:latin typeface="Calibri"/>
+                        </a:rPr>
+                        <a:t>Projeto 12</a:t>
+                      </a:r>
+                    </a:p>
+                  </a:txBody>
+                  <a:tcPr marL="73152" marR="73152" marT="27432" marB="27432" anchor="ctr">
+                    <a:solidFill>
+                      <a:srgbClr val="F2F2F2"/>
+                    </a:solidFill>
+                  </a:tcPr>
+                </a:tc>
+                <a:tc>
+                  <a:txBody>
+                    <a:bodyPr wrap="square"/>
+                    <a:lstStyle/>
+                    <a:p>
+                      <a:pPr algn="l"/>
+                      <a:r>
+                        <a:rPr sz="1200" b="0" i="0">
+                          <a:solidFill>
+                            <a:srgbClr val="333333"/>
+                          </a:solidFill>
+                          <a:latin typeface="Calibri"/>
+                        </a:rPr>
+                        <a:t>Validação</a:t>
+                      </a:r>
+                    </a:p>
+                  </a:txBody>
+                  <a:tcPr marL="73152" marR="73152" marT="27432" marB="27432" anchor="ctr">
+                    <a:solidFill>
+                      <a:srgbClr val="F2F2F2"/>
+                    </a:solidFill>
+                  </a:tcPr>
+                </a:tc>
+                <a:tc>
+                  <a:txBody>
+                    <a:bodyPr wrap="square"/>
+                    <a:lstStyle/>
+                    <a:p>
+                      <a:pPr algn="ctr"/>
+                      <a:r>
+                        <a:rPr sz="1200" b="1" i="0">
+                          <a:solidFill>
+                            <a:srgbClr val="FFFFFF"/>
+                          </a:solidFill>
+                          <a:latin typeface="Calibri"/>
+                        </a:rPr>
+                        <a:t>Alto</a:t>
+                      </a:r>
+                    </a:p>
+                  </a:txBody>
+                  <a:tcPr marL="73152" marR="73152" marT="27432" marB="27432" anchor="ctr">
+                    <a:solidFill>
+                      <a:srgbClr val="C62828"/>
+                    </a:solidFill>
+                  </a:tcPr>
+                </a:tc>
+                <a:tc>
+                  <a:txBody>
+                    <a:bodyPr wrap="square"/>
+                    <a:lstStyle/>
+                    <a:p>
+                      <a:pPr algn="r"/>
+                      <a:r>
+                        <a:rPr sz="1200" b="0" i="0">
+                          <a:solidFill>
+                            <a:srgbClr val="333333"/>
+                          </a:solidFill>
+                          <a:latin typeface="Calibri"/>
+                        </a:rPr>
+                        <a:t>42%</a:t>
+                      </a:r>
+                    </a:p>
+                  </a:txBody>
+                  <a:tcPr marL="73152" marR="73152" marT="27432" marB="27432" anchor="ctr">
+                    <a:solidFill>
+                      <a:srgbClr val="F2F2F2"/>
+                    </a:solidFill>
+                  </a:tcPr>
+                </a:tc>
+                <a:tc>
+                  <a:txBody>
+                    <a:bodyPr wrap="square"/>
+                    <a:lstStyle/>
+                    <a:p>
+                      <a:pPr algn="r"/>
+                      <a:r>
+                        <a:rPr sz="1200" b="0" i="0">
+                          <a:solidFill>
+                            <a:srgbClr val="333333"/>
+                          </a:solidFill>
+                          <a:latin typeface="Calibri"/>
+                        </a:rPr>
+                        <a:t>R$ 2,2 mi</a:t>
+                      </a:r>
+                    </a:p>
+                  </a:txBody>
+                  <a:tcPr marL="73152" marR="73152" marT="27432" marB="27432" anchor="ctr">
+                    <a:solidFill>
+                      <a:srgbClr val="F2F2F2"/>
+                    </a:solidFill>
+                  </a:tcPr>
+                </a:tc>
+              </a:tr>
+              <a:tr h="399010">
+                <a:tc>
+                  <a:txBody>
+                    <a:bodyPr wrap="square"/>
+                    <a:lstStyle/>
+                    <a:p>
+                      <a:pPr algn="l"/>
+                      <a:r>
+                        <a:rPr sz="1200" b="0" i="0">
+                          <a:solidFill>
+                            <a:srgbClr val="333333"/>
+                          </a:solidFill>
+                          <a:latin typeface="Calibri"/>
+                        </a:rPr>
+                        <a:t>P-013</a:t>
+                      </a:r>
+                    </a:p>
+                  </a:txBody>
+                  <a:tcPr marL="73152" marR="73152" marT="27432" marB="27432" anchor="ctr">
+                    <a:solidFill>
+                      <a:srgbClr val="FFFFFF"/>
+                    </a:solidFill>
+                  </a:tcPr>
+                </a:tc>
+                <a:tc>
+                  <a:txBody>
+                    <a:bodyPr wrap="square"/>
+                    <a:lstStyle/>
+                    <a:p>
+                      <a:pPr algn="l"/>
+                      <a:r>
+                        <a:rPr sz="1200" b="0" i="0">
+                          <a:solidFill>
+                            <a:srgbClr val="333333"/>
+                          </a:solidFill>
+                          <a:latin typeface="Calibri"/>
+                        </a:rPr>
+                        <a:t>Projeto 13</a:t>
+                      </a:r>
+                    </a:p>
+                  </a:txBody>
+                  <a:tcPr marL="73152" marR="73152" marT="27432" marB="27432" anchor="ctr">
+                    <a:solidFill>
+                      <a:srgbClr val="FFFFFF"/>
+                    </a:solidFill>
+                  </a:tcPr>
+                </a:tc>
+                <a:tc>
+                  <a:txBody>
+                    <a:bodyPr wrap="square"/>
+                    <a:lstStyle/>
+                    <a:p>
+                      <a:pPr algn="l"/>
+                      <a:r>
+                        <a:rPr sz="1200" b="0" i="0">
+                          <a:solidFill>
+                            <a:srgbClr val="333333"/>
+                          </a:solidFill>
+                          <a:latin typeface="Calibri"/>
+                        </a:rPr>
+                        <a:t>Em andamento</a:t>
+                      </a:r>
+                    </a:p>
+                  </a:txBody>
+                  <a:tcPr marL="73152" marR="73152" marT="27432" marB="27432" anchor="ctr">
+                    <a:solidFill>
+                      <a:srgbClr val="FFFFFF"/>
+                    </a:solidFill>
+                  </a:tcPr>
+                </a:tc>
+                <a:tc>
+                  <a:txBody>
+                    <a:bodyPr wrap="square"/>
+                    <a:lstStyle/>
+                    <a:p>
+                      <a:pPr algn="ctr"/>
+                      <a:r>
+                        <a:rPr sz="1200" b="1" i="0">
+                          <a:solidFill>
+                            <a:srgbClr val="FFFFFF"/>
+                          </a:solidFill>
+                          <a:latin typeface="Calibri"/>
+                        </a:rPr>
+                        <a:t>Médio</a:t>
+                      </a:r>
+                    </a:p>
+                  </a:txBody>
+                  <a:tcPr marL="73152" marR="73152" marT="27432" marB="27432" anchor="ctr">
+                    <a:solidFill>
+                      <a:srgbClr val="F9A825"/>
+                    </a:solidFill>
+                  </a:tcPr>
+                </a:tc>
+                <a:tc>
+                  <a:txBody>
+                    <a:bodyPr wrap="square"/>
+                    <a:lstStyle/>
+                    <a:p>
+                      <a:pPr algn="r"/>
+                      <a:r>
+                        <a:rPr sz="1200" b="0" i="0">
+                          <a:solidFill>
+                            <a:srgbClr val="333333"/>
+                          </a:solidFill>
+                          <a:latin typeface="Calibri"/>
+                        </a:rPr>
+                        <a:t>43%</a:t>
+                      </a:r>
+                    </a:p>
+                  </a:txBody>
+                  <a:tcPr marL="73152" marR="73152" marT="27432" marB="27432" anchor="ctr">
+                    <a:solidFill>
+                      <a:srgbClr val="FFFFFF"/>
+                    </a:solidFill>
+                  </a:tcPr>
+                </a:tc>
+                <a:tc>
+                  <a:txBody>
+                    <a:bodyPr wrap="square"/>
+                    <a:lstStyle/>
+                    <a:p>
+                      <a:pPr algn="r"/>
+                      <a:r>
+                        <a:rPr sz="1200" b="0" i="0">
+                          <a:solidFill>
+                            <a:srgbClr val="333333"/>
+                          </a:solidFill>
+                          <a:latin typeface="Calibri"/>
+                        </a:rPr>
+                        <a:t>R$ 2,3 mi</a:t>
+                      </a:r>
+                    </a:p>
+                  </a:txBody>
+                  <a:tcPr marL="73152" marR="73152" marT="27432" marB="27432" anchor="ctr">
+                    <a:solidFill>
+                      <a:srgbClr val="FFFFFF"/>
+                    </a:solidFill>
+                  </a:tcPr>
+                </a:tc>
+              </a:tr>
+              <a:tr h="399010">
+                <a:tc>
+                  <a:txBody>
+                    <a:bodyPr wrap="square"/>
+                    <a:lstStyle/>
+                    <a:p>
+                      <a:pPr algn="l"/>
+                      <a:r>
+                        <a:rPr sz="1200" b="0" i="0">
+                          <a:solidFill>
+                            <a:srgbClr val="333333"/>
+                          </a:solidFill>
+                          <a:latin typeface="Calibri"/>
+                        </a:rPr>
+                        <a:t>P-014</a:t>
+                      </a:r>
+                    </a:p>
+                  </a:txBody>
+                  <a:tcPr marL="73152" marR="73152" marT="27432" marB="27432" anchor="ctr">
+                    <a:solidFill>
+                      <a:srgbClr val="F2F2F2"/>
+                    </a:solidFill>
+                  </a:tcPr>
+                </a:tc>
+                <a:tc>
+                  <a:txBody>
+                    <a:bodyPr wrap="square"/>
+                    <a:lstStyle/>
+                    <a:p>
+                      <a:pPr algn="l"/>
+                      <a:r>
+                        <a:rPr sz="1200" b="0" i="0">
+                          <a:solidFill>
+                            <a:srgbClr val="333333"/>
+                          </a:solidFill>
+                          <a:latin typeface="Calibri"/>
+                        </a:rPr>
+                        <a:t>Projeto 14</a:t>
+                      </a:r>
+                    </a:p>
+                  </a:txBody>
+                  <a:tcPr marL="73152" marR="73152" marT="27432" marB="27432" anchor="ctr">
+                    <a:solidFill>
+                      <a:srgbClr val="F2F2F2"/>
+                    </a:solidFill>
+                  </a:tcPr>
+                </a:tc>
+                <a:tc>
+                  <a:txBody>
+                    <a:bodyPr wrap="square"/>
+                    <a:lstStyle/>
+                    <a:p>
+                      <a:pPr algn="l"/>
+                      <a:r>
+                        <a:rPr sz="1200" b="0" i="0">
+                          <a:solidFill>
+                            <a:srgbClr val="333333"/>
+                          </a:solidFill>
+                          <a:latin typeface="Calibri"/>
+                        </a:rPr>
+                        <a:t>Em andamento</a:t>
+                      </a:r>
+                    </a:p>
+                  </a:txBody>
+                  <a:tcPr marL="73152" marR="73152" marT="27432" marB="27432" anchor="ctr">
+                    <a:solidFill>
+                      <a:srgbClr val="F2F2F2"/>
+                    </a:solidFill>
+                  </a:tcPr>
+                </a:tc>
+                <a:tc>
+                  <a:txBody>
+                    <a:bodyPr wrap="square"/>
+                    <a:lstStyle/>
+                    <a:p>
+                      <a:pPr algn="ctr"/>
+                      <a:r>
+                        <a:rPr sz="1200" b="1" i="0">
+                          <a:solidFill>
+                            <a:srgbClr val="FFFFFF"/>
+                          </a:solidFill>
+                          <a:latin typeface="Calibri"/>
+                        </a:rPr>
+                        <a:t>Médio</a:t>
+                      </a:r>
+                    </a:p>
+                  </a:txBody>
+                  <a:tcPr marL="73152" marR="73152" marT="27432" marB="27432" anchor="ctr">
+                    <a:solidFill>
+                      <a:srgbClr val="F9A825"/>
+                    </a:solidFill>
+                  </a:tcPr>
+                </a:tc>
+                <a:tc>
+                  <a:txBody>
+                    <a:bodyPr wrap="square"/>
+                    <a:lstStyle/>
+                    <a:p>
+                      <a:pPr algn="r"/>
+                      <a:r>
+                        <a:rPr sz="1200" b="0" i="0">
+                          <a:solidFill>
+                            <a:srgbClr val="333333"/>
+                          </a:solidFill>
+                          <a:latin typeface="Calibri"/>
+                        </a:rPr>
+                        <a:t>44%</a:t>
+                      </a:r>
+                    </a:p>
+                  </a:txBody>
+                  <a:tcPr marL="73152" marR="73152" marT="27432" marB="27432" anchor="ctr">
+                    <a:solidFill>
+                      <a:srgbClr val="F2F2F2"/>
+                    </a:solidFill>
+                  </a:tcPr>
+                </a:tc>
+                <a:tc>
+                  <a:txBody>
+                    <a:bodyPr wrap="square"/>
+                    <a:lstStyle/>
+                    <a:p>
+                      <a:pPr algn="r"/>
+                      <a:r>
+                        <a:rPr sz="1200" b="0" i="0">
+                          <a:solidFill>
+                            <a:srgbClr val="333333"/>
+                          </a:solidFill>
+                          <a:latin typeface="Calibri"/>
+                        </a:rPr>
+                        <a:t>R$ 2,4 mi</a:t>
+                      </a:r>
+                    </a:p>
+                  </a:txBody>
+                  <a:tcPr marL="73152" marR="73152" marT="27432" marB="27432" anchor="ctr">
+                    <a:solidFill>
+                      <a:srgbClr val="F2F2F2"/>
+                    </a:solidFill>
+                  </a:tcPr>
+                </a:tc>
+              </a:tr>
+              <a:tr h="399010">
+                <a:tc>
+                  <a:txBody>
+                    <a:bodyPr wrap="square"/>
+                    <a:lstStyle/>
+                    <a:p>
+                      <a:pPr algn="l"/>
+                      <a:r>
+                        <a:rPr sz="1200" b="0" i="0">
+                          <a:solidFill>
+                            <a:srgbClr val="333333"/>
+                          </a:solidFill>
+                          <a:latin typeface="Calibri"/>
+                        </a:rPr>
+                        <a:t>P-015</a:t>
+                      </a:r>
+                    </a:p>
+                  </a:txBody>
+                  <a:tcPr marL="73152" marR="73152" marT="27432" marB="27432" anchor="ctr">
+                    <a:solidFill>
+                      <a:srgbClr val="FFFFFF"/>
+                    </a:solidFill>
+                  </a:tcPr>
+                </a:tc>
+                <a:tc>
+                  <a:txBody>
+                    <a:bodyPr wrap="square"/>
+                    <a:lstStyle/>
+                    <a:p>
+                      <a:pPr algn="l"/>
+                      <a:r>
+                        <a:rPr sz="1200" b="0" i="0">
+                          <a:solidFill>
+                            <a:srgbClr val="333333"/>
+                          </a:solidFill>
+                          <a:latin typeface="Calibri"/>
+                        </a:rPr>
+                        <a:t>Projeto 15</a:t>
+                      </a:r>
+                    </a:p>
+                  </a:txBody>
+                  <a:tcPr marL="73152" marR="73152" marT="27432" marB="27432" anchor="ctr">
+                    <a:solidFill>
+                      <a:srgbClr val="FFFFFF"/>
+                    </a:solidFill>
+                  </a:tcPr>
+                </a:tc>
+                <a:tc>
+                  <a:txBody>
+                    <a:bodyPr wrap="square"/>
+                    <a:lstStyle/>
+                    <a:p>
+                      <a:pPr algn="l"/>
+                      <a:r>
+                        <a:rPr sz="1200" b="0" i="0">
+                          <a:solidFill>
+                            <a:srgbClr val="333333"/>
+                          </a:solidFill>
+                          <a:latin typeface="Calibri"/>
+                        </a:rPr>
+                        <a:t>Validação</a:t>
+                      </a:r>
+                    </a:p>
+                  </a:txBody>
+                  <a:tcPr marL="73152" marR="73152" marT="27432" marB="27432" anchor="ctr">
+                    <a:solidFill>
+                      <a:srgbClr val="FFFFFF"/>
+                    </a:solidFill>
+                  </a:tcPr>
+                </a:tc>
+                <a:tc>
+                  <a:txBody>
+                    <a:bodyPr wrap="square"/>
+                    <a:lstStyle/>
+                    <a:p>
+                      <a:pPr algn="ctr"/>
+                      <a:r>
+                        <a:rPr sz="1200" b="1" i="0">
+                          <a:solidFill>
+                            <a:srgbClr val="FFFFFF"/>
+                          </a:solidFill>
+                          <a:latin typeface="Calibri"/>
+                        </a:rPr>
+                        <a:t>Médio</a:t>
+                      </a:r>
+                    </a:p>
+                  </a:txBody>
+                  <a:tcPr marL="73152" marR="73152" marT="27432" marB="27432" anchor="ctr">
+                    <a:solidFill>
+                      <a:srgbClr val="F9A825"/>
+                    </a:solidFill>
+                  </a:tcPr>
+                </a:tc>
+                <a:tc>
+                  <a:txBody>
+                    <a:bodyPr wrap="square"/>
+                    <a:lstStyle/>
+                    <a:p>
+                      <a:pPr algn="r"/>
+                      <a:r>
+                        <a:rPr sz="1200" b="0" i="0">
+                          <a:solidFill>
+                            <a:srgbClr val="333333"/>
+                          </a:solidFill>
+                          <a:latin typeface="Calibri"/>
+                        </a:rPr>
+                        <a:t>45%</a:t>
+                      </a:r>
+                    </a:p>
+                  </a:txBody>
+                  <a:tcPr marL="73152" marR="73152" marT="27432" marB="27432" anchor="ctr">
+                    <a:solidFill>
+                      <a:srgbClr val="FFFFFF"/>
+                    </a:solidFill>
+                  </a:tcPr>
+                </a:tc>
+                <a:tc>
+                  <a:txBody>
+                    <a:bodyPr wrap="square"/>
+                    <a:lstStyle/>
+                    <a:p>
+                      <a:pPr algn="r"/>
+                      <a:r>
+                        <a:rPr sz="1200" b="0" i="0">
+                          <a:solidFill>
+                            <a:srgbClr val="333333"/>
+                          </a:solidFill>
+                          <a:latin typeface="Calibri"/>
+                        </a:rPr>
+                        <a:t>R$ 2,5 mi</a:t>
+                      </a:r>
+                    </a:p>
+                  </a:txBody>
+                  <a:tcPr marL="73152" marR="73152" marT="27432" marB="27432" anchor="ctr">
+                    <a:solidFill>
+                      <a:srgbClr val="FFFFFF"/>
+                    </a:solidFill>
+                  </a:tcPr>
+                </a:tc>
+              </a:tr>
+              <a:tr h="399010">
+                <a:tc>
+                  <a:txBody>
+                    <a:bodyPr wrap="square"/>
+                    <a:lstStyle/>
+                    <a:p>
+                      <a:pPr algn="l"/>
+                      <a:r>
+                        <a:rPr sz="1200" b="0" i="0">
+                          <a:solidFill>
+                            <a:srgbClr val="333333"/>
+                          </a:solidFill>
+                          <a:latin typeface="Calibri"/>
+                        </a:rPr>
+                        <a:t>P-016</a:t>
+                      </a:r>
+                    </a:p>
+                  </a:txBody>
+                  <a:tcPr marL="73152" marR="73152" marT="27432" marB="27432" anchor="ctr">
+                    <a:solidFill>
+                      <a:srgbClr val="F2F2F2"/>
+                    </a:solidFill>
+                  </a:tcPr>
+                </a:tc>
+                <a:tc>
+                  <a:txBody>
+                    <a:bodyPr wrap="square"/>
+                    <a:lstStyle/>
+                    <a:p>
+                      <a:pPr algn="l"/>
+                      <a:r>
+                        <a:rPr sz="1200" b="0" i="0">
+                          <a:solidFill>
+                            <a:srgbClr val="333333"/>
+                          </a:solidFill>
+                          <a:latin typeface="Calibri"/>
+                        </a:rPr>
+                        <a:t>Projeto 16</a:t>
+                      </a:r>
+                    </a:p>
+                  </a:txBody>
+                  <a:tcPr marL="73152" marR="73152" marT="27432" marB="27432" anchor="ctr">
+                    <a:solidFill>
+                      <a:srgbClr val="F2F2F2"/>
+                    </a:solidFill>
+                  </a:tcPr>
+                </a:tc>
+                <a:tc>
+                  <a:txBody>
+                    <a:bodyPr wrap="square"/>
+                    <a:lstStyle/>
+                    <a:p>
+                      <a:pPr algn="l"/>
+                      <a:r>
+                        <a:rPr sz="1200" b="0" i="0">
+                          <a:solidFill>
+                            <a:srgbClr val="333333"/>
+                          </a:solidFill>
+                          <a:latin typeface="Calibri"/>
+                        </a:rPr>
+                        <a:t>Em andamento</a:t>
+                      </a:r>
+                    </a:p>
+                  </a:txBody>
+                  <a:tcPr marL="73152" marR="73152" marT="27432" marB="27432" anchor="ctr">
+                    <a:solidFill>
+                      <a:srgbClr val="F2F2F2"/>
+                    </a:solidFill>
+                  </a:tcPr>
+                </a:tc>
+                <a:tc>
+                  <a:txBody>
+                    <a:bodyPr wrap="square"/>
+                    <a:lstStyle/>
+                    <a:p>
+                      <a:pPr algn="ctr"/>
+                      <a:r>
+                        <a:rPr sz="1200" b="1" i="0">
+                          <a:solidFill>
+                            <a:srgbClr val="FFFFFF"/>
+                          </a:solidFill>
+                          <a:latin typeface="Calibri"/>
+                        </a:rPr>
+                        <a:t>Alto</a:t>
+                      </a:r>
+                    </a:p>
+                  </a:txBody>
+                  <a:tcPr marL="73152" marR="73152" marT="27432" marB="27432" anchor="ctr">
+                    <a:solidFill>
+                      <a:srgbClr val="C62828"/>
+                    </a:solidFill>
+                  </a:tcPr>
+                </a:tc>
+                <a:tc>
+                  <a:txBody>
+                    <a:bodyPr wrap="square"/>
+                    <a:lstStyle/>
+                    <a:p>
+                      <a:pPr algn="r"/>
+                      <a:r>
+                        <a:rPr sz="1200" b="0" i="0">
+                          <a:solidFill>
+                            <a:srgbClr val="333333"/>
+                          </a:solidFill>
+                          <a:latin typeface="Calibri"/>
+                        </a:rPr>
+                        <a:t>46%</a:t>
+                      </a:r>
+                    </a:p>
+                  </a:txBody>
+                  <a:tcPr marL="73152" marR="73152" marT="27432" marB="27432" anchor="ctr">
+                    <a:solidFill>
+                      <a:srgbClr val="F2F2F2"/>
+                    </a:solidFill>
+                  </a:tcPr>
+                </a:tc>
+                <a:tc>
+                  <a:txBody>
+                    <a:bodyPr wrap="square"/>
+                    <a:lstStyle/>
+                    <a:p>
+                      <a:pPr algn="r"/>
+                      <a:r>
+                        <a:rPr sz="1200" b="0" i="0">
+                          <a:solidFill>
+                            <a:srgbClr val="333333"/>
+                          </a:solidFill>
+                          <a:latin typeface="Calibri"/>
+                        </a:rPr>
+                        <a:t>R$ 2,6 mi</a:t>
+                      </a:r>
+                    </a:p>
+                  </a:txBody>
+                  <a:tcPr marL="73152" marR="73152" marT="27432" marB="27432" anchor="ctr">
+                    <a:solidFill>
+                      <a:srgbClr val="F2F2F2"/>
+                    </a:solidFill>
+                  </a:tcPr>
+                </a:tc>
+              </a:tr>
+              <a:tr h="399010">
+                <a:tc>
+                  <a:txBody>
+                    <a:bodyPr wrap="square"/>
+                    <a:lstStyle/>
+                    <a:p>
+                      <a:pPr algn="l"/>
+                      <a:r>
+                        <a:rPr sz="1200" b="0" i="0">
+                          <a:solidFill>
+                            <a:srgbClr val="333333"/>
+                          </a:solidFill>
+                          <a:latin typeface="Calibri"/>
+                        </a:rPr>
+                        <a:t>P-017</a:t>
+                      </a:r>
+                    </a:p>
+                  </a:txBody>
+                  <a:tcPr marL="73152" marR="73152" marT="27432" marB="27432" anchor="ctr">
+                    <a:solidFill>
+                      <a:srgbClr val="FFFFFF"/>
+                    </a:solidFill>
+                  </a:tcPr>
+                </a:tc>
+                <a:tc>
+                  <a:txBody>
+                    <a:bodyPr wrap="square"/>
+                    <a:lstStyle/>
+                    <a:p>
+                      <a:pPr algn="l"/>
+                      <a:r>
+                        <a:rPr sz="1200" b="0" i="0">
+                          <a:solidFill>
+                            <a:srgbClr val="333333"/>
+                          </a:solidFill>
+                          <a:latin typeface="Calibri"/>
+                        </a:rPr>
+                        <a:t>Projeto 17</a:t>
+                      </a:r>
+                    </a:p>
+                  </a:txBody>
+                  <a:tcPr marL="73152" marR="73152" marT="27432" marB="27432" anchor="ctr">
+                    <a:solidFill>
+                      <a:srgbClr val="FFFFFF"/>
+                    </a:solidFill>
+                  </a:tcPr>
+                </a:tc>
+                <a:tc>
+                  <a:txBody>
+                    <a:bodyPr wrap="square"/>
+                    <a:lstStyle/>
+                    <a:p>
+                      <a:pPr algn="l"/>
+                      <a:r>
+                        <a:rPr sz="1200" b="0" i="0">
+                          <a:solidFill>
+                            <a:srgbClr val="333333"/>
+                          </a:solidFill>
+                          <a:latin typeface="Calibri"/>
+                        </a:rPr>
+                        <a:t>Em andamento</a:t>
+                      </a:r>
+                    </a:p>
+                  </a:txBody>
+                  <a:tcPr marL="73152" marR="73152" marT="27432" marB="27432" anchor="ctr">
+                    <a:solidFill>
+                      <a:srgbClr val="FFFFFF"/>
+                    </a:solidFill>
+                  </a:tcPr>
+                </a:tc>
+                <a:tc>
+                  <a:txBody>
+                    <a:bodyPr wrap="square"/>
+                    <a:lstStyle/>
+                    <a:p>
+                      <a:pPr algn="ctr"/>
+                      <a:r>
+                        <a:rPr sz="1200" b="1" i="0">
+                          <a:solidFill>
+                            <a:srgbClr val="FFFFFF"/>
+                          </a:solidFill>
+                          <a:latin typeface="Calibri"/>
+                        </a:rPr>
+                        <a:t>Médio</a:t>
+                      </a:r>
+                    </a:p>
+                  </a:txBody>
+                  <a:tcPr marL="73152" marR="73152" marT="27432" marB="27432" anchor="ctr">
+                    <a:solidFill>
+                      <a:srgbClr val="F9A825"/>
+                    </a:solidFill>
+                  </a:tcPr>
+                </a:tc>
+                <a:tc>
+                  <a:txBody>
+                    <a:bodyPr wrap="square"/>
+                    <a:lstStyle/>
+                    <a:p>
+                      <a:pPr algn="r"/>
+                      <a:r>
+                        <a:rPr sz="1200" b="0" i="0">
+                          <a:solidFill>
+                            <a:srgbClr val="333333"/>
+                          </a:solidFill>
+                          <a:latin typeface="Calibri"/>
+                        </a:rPr>
+                        <a:t>47%</a:t>
+                      </a:r>
+                    </a:p>
+                  </a:txBody>
+                  <a:tcPr marL="73152" marR="73152" marT="27432" marB="27432" anchor="ctr">
+                    <a:solidFill>
+                      <a:srgbClr val="FFFFFF"/>
+                    </a:solidFill>
+                  </a:tcPr>
+                </a:tc>
+                <a:tc>
+                  <a:txBody>
+                    <a:bodyPr wrap="square"/>
+                    <a:lstStyle/>
+                    <a:p>
+                      <a:pPr algn="r"/>
+                      <a:r>
+                        <a:rPr sz="1200" b="0" i="0">
+                          <a:solidFill>
+                            <a:srgbClr val="333333"/>
+                          </a:solidFill>
+                          <a:latin typeface="Calibri"/>
+                        </a:rPr>
+                        <a:t>R$ 2,7 mi</a:t>
+                      </a:r>
+                    </a:p>
+                  </a:txBody>
+                  <a:tcPr marL="73152" marR="73152" marT="27432" marB="27432" anchor="ctr">
+                    <a:solidFill>
+                      <a:srgbClr val="FFFFFF"/>
+                    </a:solidFill>
+                  </a:tcPr>
+                </a:tc>
+              </a:tr>
+              <a:tr h="399010">
+                <a:tc>
+                  <a:txBody>
+                    <a:bodyPr wrap="square"/>
+                    <a:lstStyle/>
+                    <a:p>
+                      <a:pPr algn="l"/>
+                      <a:r>
+                        <a:rPr sz="1200" b="0" i="0">
+                          <a:solidFill>
+                            <a:srgbClr val="333333"/>
+                          </a:solidFill>
+                          <a:latin typeface="Calibri"/>
+                        </a:rPr>
+                        <a:t>P-018</a:t>
+                      </a:r>
+                    </a:p>
+                  </a:txBody>
+                  <a:tcPr marL="73152" marR="73152" marT="27432" marB="27432" anchor="ctr">
+                    <a:solidFill>
+                      <a:srgbClr val="F2F2F2"/>
+                    </a:solidFill>
+                  </a:tcPr>
+                </a:tc>
+                <a:tc>
+                  <a:txBody>
+                    <a:bodyPr wrap="square"/>
+                    <a:lstStyle/>
+                    <a:p>
+                      <a:pPr algn="l"/>
+                      <a:r>
+                        <a:rPr sz="1200" b="0" i="0">
+                          <a:solidFill>
+                            <a:srgbClr val="333333"/>
+                          </a:solidFill>
+                          <a:latin typeface="Calibri"/>
+                        </a:rPr>
+                        <a:t>Projeto 18</a:t>
+                      </a:r>
+                    </a:p>
+                  </a:txBody>
+                  <a:tcPr marL="73152" marR="73152" marT="27432" marB="27432" anchor="ctr">
+                    <a:solidFill>
+                      <a:srgbClr val="F2F2F2"/>
+                    </a:solidFill>
+                  </a:tcPr>
+                </a:tc>
+                <a:tc>
+                  <a:txBody>
+                    <a:bodyPr wrap="square"/>
+                    <a:lstStyle/>
+                    <a:p>
+                      <a:pPr algn="l"/>
+                      <a:r>
+                        <a:rPr sz="1200" b="0" i="0">
+                          <a:solidFill>
+                            <a:srgbClr val="333333"/>
+                          </a:solidFill>
+                          <a:latin typeface="Calibri"/>
+                        </a:rPr>
+                        <a:t>Validação</a:t>
+                      </a:r>
+                    </a:p>
+                  </a:txBody>
+                  <a:tcPr marL="73152" marR="73152" marT="27432" marB="27432" anchor="ctr">
+                    <a:solidFill>
+                      <a:srgbClr val="F2F2F2"/>
+                    </a:solidFill>
+                  </a:tcPr>
+                </a:tc>
+                <a:tc>
+                  <a:txBody>
+                    <a:bodyPr wrap="square"/>
+                    <a:lstStyle/>
+                    <a:p>
+                      <a:pPr algn="ctr"/>
+                      <a:r>
+                        <a:rPr sz="1200" b="1" i="0">
+                          <a:solidFill>
+                            <a:srgbClr val="FFFFFF"/>
+                          </a:solidFill>
+                          <a:latin typeface="Calibri"/>
+                        </a:rPr>
+                        <a:t>Médio</a:t>
+                      </a:r>
+                    </a:p>
+                  </a:txBody>
+                  <a:tcPr marL="73152" marR="73152" marT="27432" marB="27432" anchor="ctr">
+                    <a:solidFill>
+                      <a:srgbClr val="F9A825"/>
+                    </a:solidFill>
+                  </a:tcPr>
+                </a:tc>
+                <a:tc>
+                  <a:txBody>
+                    <a:bodyPr wrap="square"/>
+                    <a:lstStyle/>
+                    <a:p>
+                      <a:pPr algn="r"/>
+                      <a:r>
+                        <a:rPr sz="1200" b="0" i="0">
+                          <a:solidFill>
+                            <a:srgbClr val="333333"/>
+                          </a:solidFill>
+                          <a:latin typeface="Calibri"/>
+                        </a:rPr>
+                        <a:t>48%</a:t>
+                      </a:r>
+                    </a:p>
+                  </a:txBody>
+                  <a:tcPr marL="73152" marR="73152" marT="27432" marB="27432" anchor="ctr">
+                    <a:solidFill>
+                      <a:srgbClr val="F2F2F2"/>
+                    </a:solidFill>
+                  </a:tcPr>
+                </a:tc>
+                <a:tc>
+                  <a:txBody>
+                    <a:bodyPr wrap="square"/>
+                    <a:lstStyle/>
+                    <a:p>
+                      <a:pPr algn="r"/>
+                      <a:r>
+                        <a:rPr sz="1200" b="0" i="0">
+                          <a:solidFill>
+                            <a:srgbClr val="333333"/>
+                          </a:solidFill>
+                          <a:latin typeface="Calibri"/>
+                        </a:rPr>
+                        <a:t>R$ 2,8 mi</a:t>
+                      </a:r>
+                    </a:p>
+                  </a:txBody>
+                  <a:tcPr marL="73152" marR="73152" marT="27432" marB="27432" anchor="ctr">
+                    <a:solidFill>
+                      <a:srgbClr val="F2F2F2"/>
+                    </a:solidFill>
+                  </a:tcPr>
+                </a:tc>
+              </a:tr>
+              <a:tr h="399010">
+                <a:tc>
+                  <a:txBody>
+                    <a:bodyPr wrap="square"/>
+                    <a:lstStyle/>
+                    <a:p>
+                      <a:pPr algn="l"/>
+                      <a:r>
+                        <a:rPr sz="1200" b="0" i="0">
+                          <a:solidFill>
+                            <a:srgbClr val="333333"/>
+                          </a:solidFill>
+                          <a:latin typeface="Calibri"/>
+                        </a:rPr>
+                        <a:t>P-019</a:t>
+                      </a:r>
+                    </a:p>
+                  </a:txBody>
+                  <a:tcPr marL="73152" marR="73152" marT="27432" marB="27432" anchor="ctr">
+                    <a:solidFill>
+                      <a:srgbClr val="FFFFFF"/>
+                    </a:solidFill>
+                  </a:tcPr>
+                </a:tc>
+                <a:tc>
+                  <a:txBody>
+                    <a:bodyPr wrap="square"/>
+                    <a:lstStyle/>
+                    <a:p>
+                      <a:pPr algn="l"/>
+                      <a:r>
+                        <a:rPr sz="1200" b="0" i="0">
+                          <a:solidFill>
+                            <a:srgbClr val="333333"/>
+                          </a:solidFill>
+                          <a:latin typeface="Calibri"/>
+                        </a:rPr>
+                        <a:t>Projeto 19</a:t>
+                      </a:r>
+                    </a:p>
+                  </a:txBody>
+                  <a:tcPr marL="73152" marR="73152" marT="27432" marB="27432" anchor="ctr">
+                    <a:solidFill>
+                      <a:srgbClr val="FFFFFF"/>
+                    </a:solidFill>
+                  </a:tcPr>
+                </a:tc>
+                <a:tc>
+                  <a:txBody>
+                    <a:bodyPr wrap="square"/>
+                    <a:lstStyle/>
+                    <a:p>
+                      <a:pPr algn="l"/>
+                      <a:r>
+                        <a:rPr sz="1200" b="0" i="0">
+                          <a:solidFill>
+                            <a:srgbClr val="333333"/>
+                          </a:solidFill>
+                          <a:latin typeface="Calibri"/>
+                        </a:rPr>
+                        <a:t>Em andamento</a:t>
+                      </a:r>
+                    </a:p>
+                  </a:txBody>
+                  <a:tcPr marL="73152" marR="73152" marT="27432" marB="27432" anchor="ctr">
+                    <a:solidFill>
+                      <a:srgbClr val="FFFFFF"/>
+                    </a:solidFill>
+                  </a:tcPr>
+                </a:tc>
+                <a:tc>
+                  <a:txBody>
+                    <a:bodyPr wrap="square"/>
+                    <a:lstStyle/>
+                    <a:p>
+                      <a:pPr algn="ctr"/>
+                      <a:r>
+                        <a:rPr sz="1200" b="1" i="0">
+                          <a:solidFill>
+                            <a:srgbClr val="FFFFFF"/>
+                          </a:solidFill>
+                          <a:latin typeface="Calibri"/>
+                        </a:rPr>
+                        <a:t>Médio</a:t>
+                      </a:r>
+                    </a:p>
+                  </a:txBody>
+                  <a:tcPr marL="73152" marR="73152" marT="27432" marB="27432" anchor="ctr">
+                    <a:solidFill>
+                      <a:srgbClr val="F9A825"/>
+                    </a:solidFill>
+                  </a:tcPr>
+                </a:tc>
+                <a:tc>
+                  <a:txBody>
+                    <a:bodyPr wrap="square"/>
+                    <a:lstStyle/>
+                    <a:p>
+                      <a:pPr algn="r"/>
+                      <a:r>
+                        <a:rPr sz="1200" b="0" i="0">
+                          <a:solidFill>
+                            <a:srgbClr val="333333"/>
+                          </a:solidFill>
+                          <a:latin typeface="Calibri"/>
+                        </a:rPr>
+                        <a:t>49%</a:t>
+                      </a:r>
+                    </a:p>
+                  </a:txBody>
+                  <a:tcPr marL="73152" marR="73152" marT="27432" marB="27432" anchor="ctr">
+                    <a:solidFill>
+                      <a:srgbClr val="FFFFFF"/>
+                    </a:solidFill>
+                  </a:tcPr>
+                </a:tc>
+                <a:tc>
+                  <a:txBody>
+                    <a:bodyPr wrap="square"/>
+                    <a:lstStyle/>
+                    <a:p>
+                      <a:pPr algn="r"/>
+                      <a:r>
+                        <a:rPr sz="1200" b="0" i="0">
+                          <a:solidFill>
+                            <a:srgbClr val="333333"/>
+                          </a:solidFill>
+                          <a:latin typeface="Calibri"/>
+                        </a:rPr>
+                        <a:t>R$ 2,9 mi</a:t>
+                      </a:r>
+                    </a:p>
+                  </a:txBody>
+                  <a:tcPr marL="73152" marR="73152" marT="27432" marB="27432" anchor="ctr">
+                    <a:solidFill>
+                      <a:srgbClr val="FFFFFF"/>
+                    </a:solidFill>
+                  </a:tcPr>
+                </a:tc>
+              </a:tr>
+              <a:tr h="399020">
+                <a:tc>
+                  <a:txBody>
+                    <a:bodyPr wrap="square"/>
+                    <a:lstStyle/>
+                    <a:p>
+                      <a:pPr algn="l"/>
+                      <a:r>
+                        <a:rPr sz="1200" b="0" i="0">
+                          <a:solidFill>
+                            <a:srgbClr val="333333"/>
+                          </a:solidFill>
+                          <a:latin typeface="Calibri"/>
+                        </a:rPr>
+                        <a:t>P-020</a:t>
+                      </a:r>
+                    </a:p>
+                  </a:txBody>
+                  <a:tcPr marL="73152" marR="73152" marT="27432" marB="27432" anchor="ctr">
+                    <a:solidFill>
+                      <a:srgbClr val="F2F2F2"/>
+                    </a:solidFill>
+                  </a:tcPr>
+                </a:tc>
+                <a:tc>
+                  <a:txBody>
+                    <a:bodyPr wrap="square"/>
+                    <a:lstStyle/>
+                    <a:p>
+                      <a:pPr algn="l"/>
+                      <a:r>
+                        <a:rPr sz="1200" b="0" i="0">
+                          <a:solidFill>
+                            <a:srgbClr val="333333"/>
+                          </a:solidFill>
+                          <a:latin typeface="Calibri"/>
+                        </a:rPr>
+                        <a:t>Projeto 20</a:t>
+                      </a:r>
+                    </a:p>
+                  </a:txBody>
+                  <a:tcPr marL="73152" marR="73152" marT="27432" marB="27432" anchor="ctr">
+                    <a:solidFill>
+                      <a:srgbClr val="F2F2F2"/>
+                    </a:solidFill>
+                  </a:tcPr>
+                </a:tc>
+                <a:tc>
+                  <a:txBody>
+                    <a:bodyPr wrap="square"/>
+                    <a:lstStyle/>
+                    <a:p>
+                      <a:pPr algn="l"/>
+                      <a:r>
+                        <a:rPr sz="1200" b="0" i="0">
+                          <a:solidFill>
+                            <a:srgbClr val="333333"/>
+                          </a:solidFill>
+                          <a:latin typeface="Calibri"/>
+                        </a:rPr>
+                        <a:t>Em andamento</a:t>
+                      </a:r>
+                    </a:p>
+                  </a:txBody>
+                  <a:tcPr marL="73152" marR="73152" marT="27432" marB="27432" anchor="ctr">
+                    <a:solidFill>
+                      <a:srgbClr val="F2F2F2"/>
+                    </a:solidFill>
+                  </a:tcPr>
+                </a:tc>
+                <a:tc>
+                  <a:txBody>
+                    <a:bodyPr wrap="square"/>
+                    <a:lstStyle/>
+                    <a:p>
+                      <a:pPr algn="ctr"/>
+                      <a:r>
+                        <a:rPr sz="1200" b="1" i="0">
+                          <a:solidFill>
+                            <a:srgbClr val="FFFFFF"/>
+                          </a:solidFill>
+                          <a:latin typeface="Calibri"/>
+                        </a:rPr>
+                        <a:t>Alto</a:t>
+                      </a:r>
+                    </a:p>
+                  </a:txBody>
+                  <a:tcPr marL="73152" marR="73152" marT="27432" marB="27432" anchor="ctr">
+                    <a:solidFill>
+                      <a:srgbClr val="C62828"/>
+                    </a:solidFill>
+                  </a:tcPr>
+                </a:tc>
+                <a:tc>
+                  <a:txBody>
+                    <a:bodyPr wrap="square"/>
+                    <a:lstStyle/>
+                    <a:p>
+                      <a:pPr algn="r"/>
+                      <a:r>
+                        <a:rPr sz="1200" b="0" i="0">
+                          <a:solidFill>
+                            <a:srgbClr val="333333"/>
+                          </a:solidFill>
+                          <a:latin typeface="Calibri"/>
+                        </a:rPr>
+                        <a:t>50%</a:t>
+                      </a:r>
+                    </a:p>
+                  </a:txBody>
+                  <a:tcPr marL="73152" marR="73152" marT="27432" marB="27432" anchor="ctr">
+                    <a:solidFill>
+                      <a:srgbClr val="F2F2F2"/>
+                    </a:solidFill>
+                  </a:tcPr>
+                </a:tc>
+                <a:tc>
+                  <a:txBody>
+                    <a:bodyPr wrap="square"/>
+                    <a:lstStyle/>
+                    <a:p>
+                      <a:pPr algn="r"/>
+                      <a:r>
+                        <a:rPr sz="1200" b="0" i="0">
+                          <a:solidFill>
+                            <a:srgbClr val="333333"/>
+                          </a:solidFill>
+                          <a:latin typeface="Calibri"/>
+                        </a:rPr>
+                        <a:t>R$ 3,0 mi</a:t>
+                      </a:r>
+                    </a:p>
+                  </a:txBody>
+                  <a:tcPr marL="73152" marR="73152" marT="27432" marB="27432" anchor="ctr">
+                    <a:solidFill>
+                      <a:srgbClr val="F2F2F2"/>
+                    </a:solidFill>
+                  </a:tcPr>
+                </a:tc>
+              </a:tr>
+            </a:tbl>
+          </a:graphicData>
+        </a:graphic>
+      </p:graphicFrame>
+    </p:spTree>
+  </p:cSld>
+  <p:clrMapOvr>
+    <a:masterClrMapping/>
+  </p:clrMapOvr>
+</p:sld>
+</file>
+
+<file path=ppt/slides/slide34.xml><?xml version="1.0" encoding="utf-8"?>
+<p:sld xmlns:a="http://schemas.openxmlformats.org/drawingml/2006/main" xmlns:p="http://schemas.openxmlformats.org/presentationml/2006/main" xmlns:r="http://schemas.openxmlformats.org/officeDocument/2006/relationships">
+  <p:cSld>
+    <p:spTree>
+      <p:nvGrpSpPr>
+        <p:cNvPr id="1" name=""/>
+        <p:cNvGrpSpPr/>
+        <p:nvPr/>
+      </p:nvGrpSpPr>
+      <p:grpSpPr/>
+      <p:sp>
+        <p:nvSpPr>
+          <p:cNvPr id="2" name="Title 1"/>
+          <p:cNvSpPr>
+            <a:spLocks noGrp="1"/>
+          </p:cNvSpPr>
+          <p:nvPr>
+            <p:ph type="title"/>
+          </p:nvPr>
+        </p:nvSpPr>
+        <p:spPr>
+          <a:xfrm>
+            <a:off x="457200" y="621792"/>
+            <a:ext cx="11274552" cy="822960"/>
+          </a:xfrm>
+        </p:spPr>
+        <p:txBody>
+          <a:bodyPr wrap="square" anchor="t" lIns="45720" rIns="45720"/>
+          <a:lstStyle/>
+          <a:p>
+            <a:pPr algn="l"/>
+            <a:r>
+              <a:rPr sz="2800" b="1" i="0">
+                <a:solidFill>
+                  <a:srgbClr val="1F3A5F"/>
+                </a:solidFill>
+                <a:latin typeface="Calibri"/>
+              </a:rPr>
+              <a:t>Tabela longa paginada automaticamente (25 linhas) (3/3)</a:t>
+            </a:r>
+          </a:p>
+        </p:txBody>
+      </p:sp>
+      <p:sp>
+        <p:nvSpPr>
+          <p:cNvPr id="3" name="TextBox 2"/>
+          <p:cNvSpPr txBox="1"/>
+          <p:nvPr/>
+        </p:nvSpPr>
+        <p:spPr>
+          <a:xfrm>
+            <a:off x="457200" y="91440"/>
+            <a:ext cx="7315200" cy="228600"/>
+          </a:xfrm>
+          <a:prstGeom prst="rect">
+            <a:avLst/>
+          </a:prstGeom>
+          <a:noFill/>
+        </p:spPr>
+        <p:txBody>
+          <a:bodyPr wrap="square" anchor="ctr" lIns="45720" rIns="45720" tIns="27432" bIns="27432">
+            <a:spAutoFit/>
+          </a:bodyPr>
+          <a:lstStyle/>
+          <a:p>
+            <a:pPr algn="l"/>
+            <a:r>
+              <a:rPr sz="900" b="1" i="0">
+                <a:solidFill>
+                  <a:srgbClr val="8C8C8C"/>
+                </a:solidFill>
+                <a:latin typeface="Calibri"/>
+              </a:rPr>
+              <a:t>EMPRESA EXEMPLO  |  CATÁLOGO DE MODELOS</a:t>
+            </a:r>
+          </a:p>
+        </p:txBody>
+      </p:sp>
+      <p:sp>
+        <p:nvSpPr>
+          <p:cNvPr id="4" name="TextBox 3"/>
+          <p:cNvSpPr txBox="1"/>
+          <p:nvPr/>
+        </p:nvSpPr>
+        <p:spPr>
+          <a:xfrm>
+            <a:off x="7772400" y="91440"/>
+            <a:ext cx="3959352" cy="228600"/>
+          </a:xfrm>
+          <a:prstGeom prst="rect">
+            <a:avLst/>
+          </a:prstGeom>
+          <a:noFill/>
+        </p:spPr>
+        <p:txBody>
+          <a:bodyPr wrap="square" anchor="ctr" lIns="45720" rIns="45720" tIns="27432" bIns="27432">
+            <a:spAutoFit/>
+          </a:bodyPr>
+          <a:lstStyle/>
+          <a:p>
+            <a:pPr algn="r"/>
+            <a:r>
+              <a:rPr sz="900" b="0" i="0">
+                <a:solidFill>
+                  <a:srgbClr val="8C8C8C"/>
+                </a:solidFill>
+                <a:latin typeface="Calibri"/>
+              </a:rPr>
+              <a:t>set/2026</a:t>
+            </a:r>
+          </a:p>
+        </p:txBody>
+      </p:sp>
+      <p:sp>
+        <p:nvSpPr>
+          <p:cNvPr id="5" name="TextBox 4"/>
+          <p:cNvSpPr txBox="1"/>
+          <p:nvPr/>
+        </p:nvSpPr>
+        <p:spPr>
+          <a:xfrm>
+            <a:off x="457200" y="384048"/>
+            <a:ext cx="11274552" cy="256032"/>
+          </a:xfrm>
+          <a:prstGeom prst="rect">
+            <a:avLst/>
+          </a:prstGeom>
+          <a:noFill/>
+        </p:spPr>
+        <p:txBody>
+          <a:bodyPr wrap="square" anchor="b" lIns="45720" rIns="45720" tIns="27432" bIns="27432">
+            <a:spAutoFit/>
+          </a:bodyPr>
+          <a:lstStyle/>
+          <a:p>
+            <a:pPr algn="l"/>
+            <a:r>
+              <a:rPr sz="1000" b="1" i="0">
+                <a:solidFill>
+                  <a:srgbClr val="4F81BD"/>
+                </a:solidFill>
+                <a:latin typeface="Calibri"/>
+              </a:rPr>
+              <a:t>ANEXO</a:t>
+            </a:r>
+          </a:p>
+        </p:txBody>
+      </p:sp>
+      <p:sp>
+        <p:nvSpPr>
+          <p:cNvPr id="6" name="TextBox 5"/>
+          <p:cNvSpPr txBox="1"/>
+          <p:nvPr/>
+        </p:nvSpPr>
+        <p:spPr>
+          <a:xfrm>
+            <a:off x="457200" y="6217920"/>
+            <a:ext cx="8531352" cy="365760"/>
+          </a:xfrm>
+          <a:prstGeom prst="rect">
+            <a:avLst/>
+          </a:prstGeom>
+          <a:noFill/>
+        </p:spPr>
+        <p:txBody>
+          <a:bodyPr wrap="square" anchor="ctr" lIns="45720" rIns="45720" tIns="27432" bIns="27432">
+            <a:spAutoFit/>
+          </a:bodyPr>
+          <a:lstStyle/>
+          <a:p>
+            <a:pPr algn="l"/>
+            <a:r>
+              <a:rPr sz="1000" b="0" i="0">
+                <a:solidFill>
+                  <a:srgbClr val="8C8C8C"/>
+                </a:solidFill>
+                <a:latin typeface="Calibri"/>
+              </a:rPr>
+              <a:t>Fonte: Base de portfólio (exemplo)   |   Uso interno</a:t>
+            </a:r>
+          </a:p>
+        </p:txBody>
+      </p:sp>
+      <p:sp>
+        <p:nvSpPr>
+          <p:cNvPr id="7" name="TextBox 6"/>
+          <p:cNvSpPr txBox="1"/>
+          <p:nvPr/>
+        </p:nvSpPr>
+        <p:spPr>
+          <a:xfrm>
+            <a:off x="10817352" y="6217920"/>
+            <a:ext cx="914400" cy="365760"/>
+          </a:xfrm>
+          <a:prstGeom prst="rect">
+            <a:avLst/>
+          </a:prstGeom>
+          <a:noFill/>
+        </p:spPr>
+        <p:txBody>
+          <a:bodyPr wrap="square" anchor="ctr" lIns="45720" rIns="45720" tIns="27432" bIns="27432">
+            <a:spAutoFit/>
+          </a:bodyPr>
+          <a:lstStyle/>
+          <a:p>
+            <a:pPr algn="r"/>
+            <a:r>
+              <a:rPr sz="1000" b="0" i="0">
+                <a:solidFill>
+                  <a:srgbClr val="8C8C8C"/>
+                </a:solidFill>
+                <a:latin typeface="Calibri"/>
+              </a:rPr>
+              <a:t>34</a:t>
+            </a:r>
+          </a:p>
+        </p:txBody>
+      </p:sp>
+      <p:pic>
+        <p:nvPicPr>
+          <p:cNvPr id="8" name="Picture 7" descr="logo-placeholder.png"/>
+          <p:cNvPicPr>
+            <a:picLocks noChangeAspect="1"/>
+          </p:cNvPicPr>
+          <p:nvPr/>
+        </p:nvPicPr>
+        <p:blipFill>
+          <a:blip r:embed="rId2"/>
+          <a:stretch>
+            <a:fillRect/>
+          </a:stretch>
+        </p:blipFill>
+        <p:spPr>
+          <a:xfrm>
+            <a:off x="9692640" y="6245352"/>
+            <a:ext cx="822960" cy="274320"/>
+          </a:xfrm>
+          <a:prstGeom prst="rect">
+            <a:avLst/>
+          </a:prstGeom>
+        </p:spPr>
+      </p:pic>
+      <p:graphicFrame>
+        <p:nvGraphicFramePr>
+          <p:cNvPr id="9" name="Table 8"/>
+          <p:cNvGraphicFramePr>
+            <a:graphicFrameLocks noGrp="1"/>
+          </p:cNvGraphicFramePr>
+          <p:nvPr/>
+        </p:nvGraphicFramePr>
+        <p:xfrm>
+          <a:off x="457200" y="1737360"/>
+          <a:ext cx="11274552" cy="2743200"/>
+        </p:xfrm>
+        <a:graphic>
+          <a:graphicData uri="http://schemas.openxmlformats.org/drawingml/2006/table">
+            <a:tbl>
+              <a:tblPr firstRow="1">
+                <a:tableStyleId>{5C22544A-7EE6-4342-B048-85BDC9FD1C3A}</a:tableStyleId>
+              </a:tblPr>
+              <a:tblGrid>
+                <a:gridCol w="1879092"/>
+                <a:gridCol w="1879092"/>
+                <a:gridCol w="1879092"/>
+                <a:gridCol w="1879092"/>
+                <a:gridCol w="1879092"/>
+                <a:gridCol w="1879092"/>
+              </a:tblGrid>
+              <a:tr h="457200">
+                <a:tc>
+                  <a:txBody>
+                    <a:bodyPr wrap="square"/>
+                    <a:lstStyle/>
+                    <a:p>
+                      <a:pPr algn="l"/>
+                      <a:r>
+                        <a:rPr sz="1200" b="1" i="0">
+                          <a:solidFill>
+                            <a:srgbClr val="FFFFFF"/>
+                          </a:solidFill>
+                          <a:latin typeface="Calibri"/>
+                        </a:rPr>
+                        <a:t>ID</a:t>
+                      </a:r>
+                    </a:p>
+                  </a:txBody>
+                  <a:tcPr marL="73152" marR="73152" marT="27432" marB="27432" anchor="ctr">
+                    <a:solidFill>
+                      <a:srgbClr val="1F3A5F"/>
+                    </a:solidFill>
+                  </a:tcPr>
+                </a:tc>
+                <a:tc>
+                  <a:txBody>
+                    <a:bodyPr wrap="square"/>
+                    <a:lstStyle/>
+                    <a:p>
+                      <a:pPr algn="l"/>
+                      <a:r>
+                        <a:rPr sz="1200" b="1" i="0">
+                          <a:solidFill>
+                            <a:srgbClr val="FFFFFF"/>
+                          </a:solidFill>
+                          <a:latin typeface="Calibri"/>
+                        </a:rPr>
+                        <a:t>Projeto</a:t>
+                      </a:r>
+                    </a:p>
+                  </a:txBody>
+                  <a:tcPr marL="73152" marR="73152" marT="27432" marB="27432" anchor="ctr">
+                    <a:solidFill>
+                      <a:srgbClr val="1F3A5F"/>
+                    </a:solidFill>
+                  </a:tcPr>
+                </a:tc>
+                <a:tc>
+                  <a:txBody>
+                    <a:bodyPr wrap="square"/>
+                    <a:lstStyle/>
+                    <a:p>
+                      <a:pPr algn="l"/>
+                      <a:r>
+                        <a:rPr sz="1200" b="1" i="0">
+                          <a:solidFill>
+                            <a:srgbClr val="FFFFFF"/>
+                          </a:solidFill>
+                          <a:latin typeface="Calibri"/>
+                        </a:rPr>
+                        <a:t>Status</a:t>
+                      </a:r>
+                    </a:p>
+                  </a:txBody>
+                  <a:tcPr marL="73152" marR="73152" marT="27432" marB="27432" anchor="ctr">
+                    <a:solidFill>
+                      <a:srgbClr val="1F3A5F"/>
+                    </a:solidFill>
+                  </a:tcPr>
+                </a:tc>
+                <a:tc>
+                  <a:txBody>
+                    <a:bodyPr wrap="square"/>
+                    <a:lstStyle/>
+                    <a:p>
+                      <a:pPr algn="ctr"/>
+                      <a:r>
+                        <a:rPr sz="1200" b="1" i="0">
+                          <a:solidFill>
+                            <a:srgbClr val="FFFFFF"/>
+                          </a:solidFill>
+                          <a:latin typeface="Calibri"/>
+                        </a:rPr>
+                        <a:t>Risco</a:t>
+                      </a:r>
+                    </a:p>
+                  </a:txBody>
+                  <a:tcPr marL="73152" marR="73152" marT="27432" marB="27432" anchor="ctr">
+                    <a:solidFill>
+                      <a:srgbClr val="1F3A5F"/>
+                    </a:solidFill>
+                  </a:tcPr>
+                </a:tc>
+                <a:tc>
+                  <a:txBody>
+                    <a:bodyPr wrap="square"/>
+                    <a:lstStyle/>
+                    <a:p>
+                      <a:pPr algn="r"/>
+                      <a:r>
+                        <a:rPr sz="1200" b="1" i="0">
+                          <a:solidFill>
+                            <a:srgbClr val="FFFFFF"/>
+                          </a:solidFill>
+                          <a:latin typeface="Calibri"/>
+                        </a:rPr>
+                        <a:t>Conclusão</a:t>
+                      </a:r>
+                    </a:p>
+                  </a:txBody>
+                  <a:tcPr marL="73152" marR="73152" marT="27432" marB="27432" anchor="ctr">
+                    <a:solidFill>
+                      <a:srgbClr val="1F3A5F"/>
+                    </a:solidFill>
+                  </a:tcPr>
+                </a:tc>
+                <a:tc>
+                  <a:txBody>
+                    <a:bodyPr wrap="square"/>
+                    <a:lstStyle/>
+                    <a:p>
+                      <a:pPr algn="r"/>
+                      <a:r>
+                        <a:rPr sz="1200" b="1" i="0">
+                          <a:solidFill>
+                            <a:srgbClr val="FFFFFF"/>
+                          </a:solidFill>
+                          <a:latin typeface="Calibri"/>
+                        </a:rPr>
+                        <a:t>Orçamento</a:t>
+                      </a:r>
+                    </a:p>
+                  </a:txBody>
+                  <a:tcPr marL="73152" marR="73152" marT="27432" marB="27432" anchor="ctr">
+                    <a:solidFill>
+                      <a:srgbClr val="1F3A5F"/>
+                    </a:solidFill>
+                  </a:tcPr>
+                </a:tc>
+              </a:tr>
+              <a:tr h="457200">
+                <a:tc>
+                  <a:txBody>
+                    <a:bodyPr wrap="square"/>
+                    <a:lstStyle/>
+                    <a:p>
+                      <a:pPr algn="l"/>
+                      <a:r>
+                        <a:rPr sz="1200" b="0" i="0">
+                          <a:solidFill>
+                            <a:srgbClr val="333333"/>
+                          </a:solidFill>
+                          <a:latin typeface="Calibri"/>
+                        </a:rPr>
+                        <a:t>P-021</a:t>
+                      </a:r>
+                    </a:p>
+                  </a:txBody>
+                  <a:tcPr marL="73152" marR="73152" marT="27432" marB="27432" anchor="ctr">
+                    <a:solidFill>
+                      <a:srgbClr val="FFFFFF"/>
+                    </a:solidFill>
+                  </a:tcPr>
+                </a:tc>
+                <a:tc>
+                  <a:txBody>
+                    <a:bodyPr wrap="square"/>
+                    <a:lstStyle/>
+                    <a:p>
+                      <a:pPr algn="l"/>
+                      <a:r>
+                        <a:rPr sz="1200" b="0" i="0">
+                          <a:solidFill>
+                            <a:srgbClr val="333333"/>
+                          </a:solidFill>
+                          <a:latin typeface="Calibri"/>
+                        </a:rPr>
+                        <a:t>Projeto 21</a:t>
+                      </a:r>
+                    </a:p>
+                  </a:txBody>
+                  <a:tcPr marL="73152" marR="73152" marT="27432" marB="27432" anchor="ctr">
+                    <a:solidFill>
+                      <a:srgbClr val="FFFFFF"/>
+                    </a:solidFill>
+                  </a:tcPr>
+                </a:tc>
+                <a:tc>
+                  <a:txBody>
+                    <a:bodyPr wrap="square"/>
+                    <a:lstStyle/>
+                    <a:p>
+                      <a:pPr algn="l"/>
+                      <a:r>
+                        <a:rPr sz="1200" b="0" i="0">
+                          <a:solidFill>
+                            <a:srgbClr val="333333"/>
+                          </a:solidFill>
+                          <a:latin typeface="Calibri"/>
+                        </a:rPr>
+                        <a:t>Validação</a:t>
+                      </a:r>
+                    </a:p>
+                  </a:txBody>
+                  <a:tcPr marL="73152" marR="73152" marT="27432" marB="27432" anchor="ctr">
+                    <a:solidFill>
+                      <a:srgbClr val="FFFFFF"/>
+                    </a:solidFill>
+                  </a:tcPr>
+                </a:tc>
+                <a:tc>
+                  <a:txBody>
+                    <a:bodyPr wrap="square"/>
+                    <a:lstStyle/>
+                    <a:p>
+                      <a:pPr algn="ctr"/>
+                      <a:r>
+                        <a:rPr sz="1200" b="1" i="0">
+                          <a:solidFill>
+                            <a:srgbClr val="FFFFFF"/>
+                          </a:solidFill>
+                          <a:latin typeface="Calibri"/>
+                        </a:rPr>
+                        <a:t>Médio</a:t>
+                      </a:r>
+                    </a:p>
+                  </a:txBody>
+                  <a:tcPr marL="73152" marR="73152" marT="27432" marB="27432" anchor="ctr">
+                    <a:solidFill>
+                      <a:srgbClr val="F9A825"/>
+                    </a:solidFill>
+                  </a:tcPr>
+                </a:tc>
+                <a:tc>
+                  <a:txBody>
+                    <a:bodyPr wrap="square"/>
+                    <a:lstStyle/>
+                    <a:p>
+                      <a:pPr algn="r"/>
+                      <a:r>
+                        <a:rPr sz="1200" b="0" i="0">
+                          <a:solidFill>
+                            <a:srgbClr val="333333"/>
+                          </a:solidFill>
+                          <a:latin typeface="Calibri"/>
+                        </a:rPr>
+                        <a:t>51%</a:t>
+                      </a:r>
+                    </a:p>
+                  </a:txBody>
+                  <a:tcPr marL="73152" marR="73152" marT="27432" marB="27432" anchor="ctr">
+                    <a:solidFill>
+                      <a:srgbClr val="FFFFFF"/>
+                    </a:solidFill>
+                  </a:tcPr>
+                </a:tc>
+                <a:tc>
+                  <a:txBody>
+                    <a:bodyPr wrap="square"/>
+                    <a:lstStyle/>
+                    <a:p>
+                      <a:pPr algn="r"/>
+                      <a:r>
+                        <a:rPr sz="1200" b="0" i="0">
+                          <a:solidFill>
+                            <a:srgbClr val="333333"/>
+                          </a:solidFill>
+                          <a:latin typeface="Calibri"/>
+                        </a:rPr>
+                        <a:t>R$ 3,1 mi</a:t>
+                      </a:r>
+                    </a:p>
+                  </a:txBody>
+                  <a:tcPr marL="73152" marR="73152" marT="27432" marB="27432" anchor="ctr">
+                    <a:solidFill>
+                      <a:srgbClr val="FFFFFF"/>
+                    </a:solidFill>
+                  </a:tcPr>
+                </a:tc>
+              </a:tr>
+              <a:tr h="457200">
+                <a:tc>
+                  <a:txBody>
+                    <a:bodyPr wrap="square"/>
+                    <a:lstStyle/>
+                    <a:p>
+                      <a:pPr algn="l"/>
+                      <a:r>
+                        <a:rPr sz="1200" b="0" i="0">
+                          <a:solidFill>
+                            <a:srgbClr val="333333"/>
+                          </a:solidFill>
+                          <a:latin typeface="Calibri"/>
+                        </a:rPr>
+                        <a:t>P-022</a:t>
+                      </a:r>
+                    </a:p>
+                  </a:txBody>
+                  <a:tcPr marL="73152" marR="73152" marT="27432" marB="27432" anchor="ctr">
+                    <a:solidFill>
+                      <a:srgbClr val="F2F2F2"/>
+                    </a:solidFill>
+                  </a:tcPr>
+                </a:tc>
+                <a:tc>
+                  <a:txBody>
+                    <a:bodyPr wrap="square"/>
+                    <a:lstStyle/>
+                    <a:p>
+                      <a:pPr algn="l"/>
+                      <a:r>
+                        <a:rPr sz="1200" b="0" i="0">
+                          <a:solidFill>
+                            <a:srgbClr val="333333"/>
+                          </a:solidFill>
+                          <a:latin typeface="Calibri"/>
+                        </a:rPr>
+                        <a:t>Projeto 22</a:t>
+                      </a:r>
+                    </a:p>
+                  </a:txBody>
+                  <a:tcPr marL="73152" marR="73152" marT="27432" marB="27432" anchor="ctr">
+                    <a:solidFill>
+                      <a:srgbClr val="F2F2F2"/>
+                    </a:solidFill>
+                  </a:tcPr>
+                </a:tc>
+                <a:tc>
+                  <a:txBody>
+                    <a:bodyPr wrap="square"/>
+                    <a:lstStyle/>
+                    <a:p>
+                      <a:pPr algn="l"/>
+                      <a:r>
+                        <a:rPr sz="1200" b="0" i="0">
+                          <a:solidFill>
+                            <a:srgbClr val="333333"/>
+                          </a:solidFill>
+                          <a:latin typeface="Calibri"/>
+                        </a:rPr>
+                        <a:t>Em andamento</a:t>
+                      </a:r>
+                    </a:p>
+                  </a:txBody>
+                  <a:tcPr marL="73152" marR="73152" marT="27432" marB="27432" anchor="ctr">
+                    <a:solidFill>
+                      <a:srgbClr val="F2F2F2"/>
+                    </a:solidFill>
+                  </a:tcPr>
+                </a:tc>
+                <a:tc>
+                  <a:txBody>
+                    <a:bodyPr wrap="square"/>
+                    <a:lstStyle/>
+                    <a:p>
+                      <a:pPr algn="ctr"/>
+                      <a:r>
+                        <a:rPr sz="1200" b="1" i="0">
+                          <a:solidFill>
+                            <a:srgbClr val="FFFFFF"/>
+                          </a:solidFill>
+                          <a:latin typeface="Calibri"/>
+                        </a:rPr>
+                        <a:t>Médio</a:t>
+                      </a:r>
+                    </a:p>
+                  </a:txBody>
+                  <a:tcPr marL="73152" marR="73152" marT="27432" marB="27432" anchor="ctr">
+                    <a:solidFill>
+                      <a:srgbClr val="F9A825"/>
+                    </a:solidFill>
+                  </a:tcPr>
+                </a:tc>
+                <a:tc>
+                  <a:txBody>
+                    <a:bodyPr wrap="square"/>
+                    <a:lstStyle/>
+                    <a:p>
+                      <a:pPr algn="r"/>
+                      <a:r>
+                        <a:rPr sz="1200" b="0" i="0">
+                          <a:solidFill>
+                            <a:srgbClr val="333333"/>
+                          </a:solidFill>
+                          <a:latin typeface="Calibri"/>
+                        </a:rPr>
+                        <a:t>52%</a:t>
+                      </a:r>
+                    </a:p>
+                  </a:txBody>
+                  <a:tcPr marL="73152" marR="73152" marT="27432" marB="27432" anchor="ctr">
+                    <a:solidFill>
+                      <a:srgbClr val="F2F2F2"/>
+                    </a:solidFill>
+                  </a:tcPr>
+                </a:tc>
+                <a:tc>
+                  <a:txBody>
+                    <a:bodyPr wrap="square"/>
+                    <a:lstStyle/>
+                    <a:p>
+                      <a:pPr algn="r"/>
+                      <a:r>
+                        <a:rPr sz="1200" b="0" i="0">
+                          <a:solidFill>
+                            <a:srgbClr val="333333"/>
+                          </a:solidFill>
+                          <a:latin typeface="Calibri"/>
+                        </a:rPr>
+                        <a:t>R$ 3,2 mi</a:t>
+                      </a:r>
+                    </a:p>
+                  </a:txBody>
+                  <a:tcPr marL="73152" marR="73152" marT="27432" marB="27432" anchor="ctr">
+                    <a:solidFill>
+                      <a:srgbClr val="F2F2F2"/>
+                    </a:solidFill>
+                  </a:tcPr>
+                </a:tc>
+              </a:tr>
+              <a:tr h="457200">
+                <a:tc>
+                  <a:txBody>
+                    <a:bodyPr wrap="square"/>
+                    <a:lstStyle/>
+                    <a:p>
+                      <a:pPr algn="l"/>
+                      <a:r>
+                        <a:rPr sz="1200" b="0" i="0">
+                          <a:solidFill>
+                            <a:srgbClr val="333333"/>
+                          </a:solidFill>
+                          <a:latin typeface="Calibri"/>
+                        </a:rPr>
+                        <a:t>P-023</a:t>
+                      </a:r>
+                    </a:p>
+                  </a:txBody>
+                  <a:tcPr marL="73152" marR="73152" marT="27432" marB="27432" anchor="ctr">
+                    <a:solidFill>
+                      <a:srgbClr val="FFFFFF"/>
+                    </a:solidFill>
+                  </a:tcPr>
+                </a:tc>
+                <a:tc>
+                  <a:txBody>
+                    <a:bodyPr wrap="square"/>
+                    <a:lstStyle/>
+                    <a:p>
+                      <a:pPr algn="l"/>
+                      <a:r>
+                        <a:rPr sz="1200" b="0" i="0">
+                          <a:solidFill>
+                            <a:srgbClr val="333333"/>
+                          </a:solidFill>
+                          <a:latin typeface="Calibri"/>
+                        </a:rPr>
+                        <a:t>Projeto 23</a:t>
+                      </a:r>
+                    </a:p>
+                  </a:txBody>
+                  <a:tcPr marL="73152" marR="73152" marT="27432" marB="27432" anchor="ctr">
+                    <a:solidFill>
+                      <a:srgbClr val="FFFFFF"/>
+                    </a:solidFill>
+                  </a:tcPr>
+                </a:tc>
+                <a:tc>
+                  <a:txBody>
+                    <a:bodyPr wrap="square"/>
+                    <a:lstStyle/>
+                    <a:p>
+                      <a:pPr algn="l"/>
+                      <a:r>
+                        <a:rPr sz="1200" b="0" i="0">
+                          <a:solidFill>
+                            <a:srgbClr val="333333"/>
+                          </a:solidFill>
+                          <a:latin typeface="Calibri"/>
+                        </a:rPr>
+                        <a:t>Em andamento</a:t>
+                      </a:r>
+                    </a:p>
+                  </a:txBody>
+                  <a:tcPr marL="73152" marR="73152" marT="27432" marB="27432" anchor="ctr">
+                    <a:solidFill>
+                      <a:srgbClr val="FFFFFF"/>
+                    </a:solidFill>
+                  </a:tcPr>
+                </a:tc>
+                <a:tc>
+                  <a:txBody>
+                    <a:bodyPr wrap="square"/>
+                    <a:lstStyle/>
+                    <a:p>
+                      <a:pPr algn="ctr"/>
+                      <a:r>
+                        <a:rPr sz="1200" b="1" i="0">
+                          <a:solidFill>
+                            <a:srgbClr val="FFFFFF"/>
+                          </a:solidFill>
+                          <a:latin typeface="Calibri"/>
+                        </a:rPr>
+                        <a:t>Médio</a:t>
+                      </a:r>
+                    </a:p>
+                  </a:txBody>
+                  <a:tcPr marL="73152" marR="73152" marT="27432" marB="27432" anchor="ctr">
+                    <a:solidFill>
+                      <a:srgbClr val="F9A825"/>
+                    </a:solidFill>
+                  </a:tcPr>
+                </a:tc>
+                <a:tc>
+                  <a:txBody>
+                    <a:bodyPr wrap="square"/>
+                    <a:lstStyle/>
+                    <a:p>
+                      <a:pPr algn="r"/>
+                      <a:r>
+                        <a:rPr sz="1200" b="0" i="0">
+                          <a:solidFill>
+                            <a:srgbClr val="333333"/>
+                          </a:solidFill>
+                          <a:latin typeface="Calibri"/>
+                        </a:rPr>
+                        <a:t>53%</a:t>
+                      </a:r>
+                    </a:p>
+                  </a:txBody>
+                  <a:tcPr marL="73152" marR="73152" marT="27432" marB="27432" anchor="ctr">
+                    <a:solidFill>
+                      <a:srgbClr val="FFFFFF"/>
+                    </a:solidFill>
+                  </a:tcPr>
+                </a:tc>
+                <a:tc>
+                  <a:txBody>
+                    <a:bodyPr wrap="square"/>
+                    <a:lstStyle/>
+                    <a:p>
+                      <a:pPr algn="r"/>
+                      <a:r>
+                        <a:rPr sz="1200" b="0" i="0">
+                          <a:solidFill>
+                            <a:srgbClr val="333333"/>
+                          </a:solidFill>
+                          <a:latin typeface="Calibri"/>
+                        </a:rPr>
+                        <a:t>R$ 3,3 mi</a:t>
+                      </a:r>
+                    </a:p>
+                  </a:txBody>
+                  <a:tcPr marL="73152" marR="73152" marT="27432" marB="27432" anchor="ctr">
+                    <a:solidFill>
+                      <a:srgbClr val="FFFFFF"/>
+                    </a:solidFill>
+                  </a:tcPr>
+                </a:tc>
+              </a:tr>
+              <a:tr h="457200">
+                <a:tc>
+                  <a:txBody>
+                    <a:bodyPr wrap="square"/>
+                    <a:lstStyle/>
+                    <a:p>
+                      <a:pPr algn="l"/>
+                      <a:r>
+                        <a:rPr sz="1200" b="0" i="0">
+                          <a:solidFill>
+                            <a:srgbClr val="333333"/>
+                          </a:solidFill>
+                          <a:latin typeface="Calibri"/>
+                        </a:rPr>
+                        <a:t>P-024</a:t>
+                      </a:r>
+                    </a:p>
+                  </a:txBody>
+                  <a:tcPr marL="73152" marR="73152" marT="27432" marB="27432" anchor="ctr">
+                    <a:solidFill>
+                      <a:srgbClr val="F2F2F2"/>
+                    </a:solidFill>
+                  </a:tcPr>
+                </a:tc>
+                <a:tc>
+                  <a:txBody>
+                    <a:bodyPr wrap="square"/>
+                    <a:lstStyle/>
+                    <a:p>
+                      <a:pPr algn="l"/>
+                      <a:r>
+                        <a:rPr sz="1200" b="0" i="0">
+                          <a:solidFill>
+                            <a:srgbClr val="333333"/>
+                          </a:solidFill>
+                          <a:latin typeface="Calibri"/>
+                        </a:rPr>
+                        <a:t>Projeto 24</a:t>
+                      </a:r>
+                    </a:p>
+                  </a:txBody>
+                  <a:tcPr marL="73152" marR="73152" marT="27432" marB="27432" anchor="ctr">
+                    <a:solidFill>
+                      <a:srgbClr val="F2F2F2"/>
+                    </a:solidFill>
+                  </a:tcPr>
+                </a:tc>
+                <a:tc>
+                  <a:txBody>
+                    <a:bodyPr wrap="square"/>
+                    <a:lstStyle/>
+                    <a:p>
+                      <a:pPr algn="l"/>
+                      <a:r>
+                        <a:rPr sz="1200" b="0" i="0">
+                          <a:solidFill>
+                            <a:srgbClr val="333333"/>
+                          </a:solidFill>
+                          <a:latin typeface="Calibri"/>
+                        </a:rPr>
+                        <a:t>Validação</a:t>
+                      </a:r>
+                    </a:p>
+                  </a:txBody>
+                  <a:tcPr marL="73152" marR="73152" marT="27432" marB="27432" anchor="ctr">
+                    <a:solidFill>
+                      <a:srgbClr val="F2F2F2"/>
+                    </a:solidFill>
+                  </a:tcPr>
+                </a:tc>
+                <a:tc>
+                  <a:txBody>
+                    <a:bodyPr wrap="square"/>
+                    <a:lstStyle/>
+                    <a:p>
+                      <a:pPr algn="ctr"/>
+                      <a:r>
+                        <a:rPr sz="1200" b="1" i="0">
+                          <a:solidFill>
+                            <a:srgbClr val="FFFFFF"/>
+                          </a:solidFill>
+                          <a:latin typeface="Calibri"/>
+                        </a:rPr>
+                        <a:t>Alto</a:t>
+                      </a:r>
+                    </a:p>
+                  </a:txBody>
+                  <a:tcPr marL="73152" marR="73152" marT="27432" marB="27432" anchor="ctr">
+                    <a:solidFill>
+                      <a:srgbClr val="C62828"/>
+                    </a:solidFill>
+                  </a:tcPr>
+                </a:tc>
+                <a:tc>
+                  <a:txBody>
+                    <a:bodyPr wrap="square"/>
+                    <a:lstStyle/>
+                    <a:p>
+                      <a:pPr algn="r"/>
+                      <a:r>
+                        <a:rPr sz="1200" b="0" i="0">
+                          <a:solidFill>
+                            <a:srgbClr val="333333"/>
+                          </a:solidFill>
+                          <a:latin typeface="Calibri"/>
+                        </a:rPr>
+                        <a:t>54%</a:t>
+                      </a:r>
+                    </a:p>
+                  </a:txBody>
+                  <a:tcPr marL="73152" marR="73152" marT="27432" marB="27432" anchor="ctr">
+                    <a:solidFill>
+                      <a:srgbClr val="F2F2F2"/>
+                    </a:solidFill>
+                  </a:tcPr>
+                </a:tc>
+                <a:tc>
+                  <a:txBody>
+                    <a:bodyPr wrap="square"/>
+                    <a:lstStyle/>
+                    <a:p>
+                      <a:pPr algn="r"/>
+                      <a:r>
+                        <a:rPr sz="1200" b="0" i="0">
+                          <a:solidFill>
+                            <a:srgbClr val="333333"/>
+                          </a:solidFill>
+                          <a:latin typeface="Calibri"/>
+                        </a:rPr>
+                        <a:t>R$ 3,4 mi</a:t>
+                      </a:r>
+                    </a:p>
+                  </a:txBody>
+                  <a:tcPr marL="73152" marR="73152" marT="27432" marB="27432" anchor="ctr">
+                    <a:solidFill>
+                      <a:srgbClr val="F2F2F2"/>
+                    </a:solidFill>
+                  </a:tcPr>
+                </a:tc>
+              </a:tr>
+              <a:tr h="457200">
+                <a:tc>
+                  <a:txBody>
+                    <a:bodyPr wrap="square"/>
+                    <a:lstStyle/>
+                    <a:p>
+                      <a:pPr algn="l"/>
+                      <a:r>
+                        <a:rPr sz="1200" b="0" i="0">
+                          <a:solidFill>
+                            <a:srgbClr val="333333"/>
+                          </a:solidFill>
+                          <a:latin typeface="Calibri"/>
+                        </a:rPr>
+                        <a:t>P-025</a:t>
+                      </a:r>
+                    </a:p>
+                  </a:txBody>
+                  <a:tcPr marL="73152" marR="73152" marT="27432" marB="27432" anchor="ctr">
+                    <a:solidFill>
+                      <a:srgbClr val="FFFFFF"/>
+                    </a:solidFill>
+                  </a:tcPr>
+                </a:tc>
+                <a:tc>
+                  <a:txBody>
+                    <a:bodyPr wrap="square"/>
+                    <a:lstStyle/>
+                    <a:p>
+                      <a:pPr algn="l"/>
+                      <a:r>
+                        <a:rPr sz="1200" b="0" i="0">
+                          <a:solidFill>
+                            <a:srgbClr val="333333"/>
+                          </a:solidFill>
+                          <a:latin typeface="Calibri"/>
+                        </a:rPr>
+                        <a:t>Projeto 25</a:t>
+                      </a:r>
+                    </a:p>
+                  </a:txBody>
+                  <a:tcPr marL="73152" marR="73152" marT="27432" marB="27432" anchor="ctr">
+                    <a:solidFill>
+                      <a:srgbClr val="FFFFFF"/>
+                    </a:solidFill>
+                  </a:tcPr>
+                </a:tc>
+                <a:tc>
+                  <a:txBody>
+                    <a:bodyPr wrap="square"/>
+                    <a:lstStyle/>
+                    <a:p>
+                      <a:pPr algn="l"/>
+                      <a:r>
+                        <a:rPr sz="1200" b="0" i="0">
+                          <a:solidFill>
+                            <a:srgbClr val="333333"/>
+                          </a:solidFill>
+                          <a:latin typeface="Calibri"/>
+                        </a:rPr>
+                        <a:t>Em andamento</a:t>
+                      </a:r>
+                    </a:p>
+                  </a:txBody>
+                  <a:tcPr marL="73152" marR="73152" marT="27432" marB="27432" anchor="ctr">
+                    <a:solidFill>
+                      <a:srgbClr val="FFFFFF"/>
+                    </a:solidFill>
+                  </a:tcPr>
+                </a:tc>
+                <a:tc>
+                  <a:txBody>
+                    <a:bodyPr wrap="square"/>
+                    <a:lstStyle/>
+                    <a:p>
+                      <a:pPr algn="ctr"/>
+                      <a:r>
+                        <a:rPr sz="1200" b="1" i="0">
+                          <a:solidFill>
+                            <a:srgbClr val="FFFFFF"/>
+                          </a:solidFill>
+                          <a:latin typeface="Calibri"/>
+                        </a:rPr>
+                        <a:t>Médio</a:t>
+                      </a:r>
+                    </a:p>
+                  </a:txBody>
+                  <a:tcPr marL="73152" marR="73152" marT="27432" marB="27432" anchor="ctr">
+                    <a:solidFill>
+                      <a:srgbClr val="F9A825"/>
+                    </a:solidFill>
+                  </a:tcPr>
+                </a:tc>
+                <a:tc>
+                  <a:txBody>
+                    <a:bodyPr wrap="square"/>
+                    <a:lstStyle/>
+                    <a:p>
+                      <a:pPr algn="r"/>
+                      <a:r>
+                        <a:rPr sz="1200" b="0" i="0">
+                          <a:solidFill>
+                            <a:srgbClr val="333333"/>
+                          </a:solidFill>
+                          <a:latin typeface="Calibri"/>
+                        </a:rPr>
+                        <a:t>55%</a:t>
+                      </a:r>
+                    </a:p>
+                  </a:txBody>
+                  <a:tcPr marL="73152" marR="73152" marT="27432" marB="27432" anchor="ctr">
+                    <a:solidFill>
+                      <a:srgbClr val="FFFFFF"/>
+                    </a:solidFill>
+                  </a:tcPr>
+                </a:tc>
+                <a:tc>
+                  <a:txBody>
+                    <a:bodyPr wrap="square"/>
+                    <a:lstStyle/>
+                    <a:p>
+                      <a:pPr algn="r"/>
+                      <a:r>
+                        <a:rPr sz="1200" b="0" i="0">
+                          <a:solidFill>
+                            <a:srgbClr val="333333"/>
+                          </a:solidFill>
+                          <a:latin typeface="Calibri"/>
+                        </a:rPr>
+                        <a:t>R$ 3,5 mi</a:t>
+                      </a:r>
+                    </a:p>
+                  </a:txBody>
+                  <a:tcPr marL="73152" marR="73152" marT="27432" marB="27432" anchor="ctr">
+                    <a:solidFill>
+                      <a:srgbClr val="FFFFFF"/>
+                    </a:solidFill>
+                  </a:tcPr>
+                </a:tc>
+              </a:tr>
+            </a:tbl>
+          </a:graphicData>
+        </a:graphic>
+      </p:graphicFrame>
+    </p:spTree>
+  </p:cSld>
+  <p:clrMapOvr>
+    <a:masterClrMapping/>
+  </p:clrMapOvr>
+</p:sld>
+</file>
+
+<file path=ppt/slides/slide35.xml><?xml version="1.0" encoding="utf-8"?>
 <p:sld xmlns:a="http://schemas.openxmlformats.org/drawingml/2006/main" xmlns:p="http://schemas.openxmlformats.org/presentationml/2006/main" xmlns:r="http://schemas.openxmlformats.org/officeDocument/2006/relationships">
   <p:cSld>
     <p:bg>

</xml_diff>